<commit_message>
feat: fix broken news image with bottle photo, redesign pitch deck in app theme, and refresh stable APK release
</commit_message>
<xml_diff>
--- a/AroggyaGram_Pitch_Deck.pptx
+++ b/AroggyaGram_Pitch_Deck.pptx
@@ -3146,18 +3146,18 @@
         </p:nvSpPr>
         <p:spPr>
           <a:xfrm>
-            <a:off x="1097280" y="822960"/>
-            <a:ext cx="9997135" cy="5212080"/>
+            <a:off x="1097280" y="685800"/>
+            <a:ext cx="9997135" cy="5486400"/>
           </a:xfrm>
           <a:prstGeom prst="roundRect">
             <a:avLst/>
           </a:prstGeom>
           <a:solidFill>
-            <a:srgbClr val="0B1413"/>
+            <a:srgbClr val="FBFAF6"/>
           </a:solidFill>
-          <a:ln w="19050">
+          <a:ln w="31750">
             <a:solidFill>
-              <a:srgbClr val="10B981"/>
+              <a:srgbClr val="E0F2EE"/>
             </a:solidFill>
           </a:ln>
         </p:spPr>
@@ -3176,31 +3176,34 @@
           </a:fontRef>
         </p:style>
         <p:txBody>
-          <a:bodyPr rtlCol="0" anchor="ctr" wrap="square" lIns="731520" rIns="731520" tIns="548640"/>
+          <a:bodyPr rtlCol="0" anchor="ctr" wrap="square" lIns="731520" rIns="731520" tIns="365760"/>
           <a:lstStyle/>
           <a:p>
             <a:pPr algn="ctr">
               <a:spcAft>
-                <a:spcPts val="1600"/>
-              </a:spcAft>
-              <a:defRPr b="1" sz="1200">
-                <a:solidFill>
-                  <a:srgbClr val="10B981"/>
-                </a:solidFill>
-              </a:defRPr>
-            </a:pPr>
-            <a:r>
-              <a:t>NATIONAL LEVEL HACKATHON 2026  •  HEALTHCARE TRACK</a:t>
+                <a:spcPts val="600"/>
+              </a:spcAft>
+              <a:defRPr b="1" sz="1100">
+                <a:solidFill>
+                  <a:srgbClr val="005448"/>
+                </a:solidFill>
+              </a:defRPr>
+            </a:pPr>
+            <a:br/>
+            <a:br/>
+            <a:br/>
+            <a:r>
+              <a:t>NATIONAL LEVEL HACKATHON 2026  •  HEALTHCARE &amp; AI TRACK</a:t>
             </a:r>
           </a:p>
           <a:p>
             <a:pPr algn="ctr">
               <a:spcAft>
-                <a:spcPts val="800"/>
-              </a:spcAft>
-              <a:defRPr b="1" sz="5600">
-                <a:solidFill>
-                  <a:srgbClr val="FFFFFF"/>
+                <a:spcPts val="400"/>
+              </a:spcAft>
+              <a:defRPr b="1" sz="5000">
+                <a:solidFill>
+                  <a:srgbClr val="121E1C"/>
                 </a:solidFill>
               </a:defRPr>
             </a:pPr>
@@ -3211,59 +3214,79 @@
           <a:p>
             <a:pPr algn="ctr">
               <a:spcAft>
+                <a:spcPts val="1400"/>
+              </a:spcAft>
+              <a:defRPr b="1" sz="2000">
+                <a:solidFill>
+                  <a:srgbClr val="005448"/>
+                </a:solidFill>
+              </a:defRPr>
+            </a:pPr>
+            <a:r>
+              <a:t>Intelligent Community Health-Response Network</a:t>
+            </a:r>
+          </a:p>
+          <a:p>
+            <a:pPr algn="ctr">
+              <a:spcAft>
                 <a:spcPts val="2000"/>
               </a:spcAft>
-              <a:defRPr b="1" sz="2200">
-                <a:solidFill>
-                  <a:srgbClr val="34D399"/>
-                </a:solidFill>
-              </a:defRPr>
-            </a:pPr>
-            <a:r>
-              <a:t>Rural India's AI-Powered Emergency Health Response Network</a:t>
-            </a:r>
-          </a:p>
-          <a:p>
-            <a:pPr algn="ctr">
-              <a:spcAft>
-                <a:spcPts val="2800"/>
-              </a:spcAft>
-              <a:defRPr sz="1500">
-                <a:solidFill>
-                  <a:srgbClr val="FBFAF6"/>
-                </a:solidFill>
-              </a:defRPr>
-            </a:pPr>
-            <a:r>
-              <a:t>“When the nearest hospital is 40 km away and an ambulance takes 90 minutes —</a:t>
-            </a:r>
-            <a:br/>
-            <a:r>
-              <a:t>AroggyaGram responds in 40 seconds.”</a:t>
-            </a:r>
-          </a:p>
-        </p:txBody>
-      </p:sp>
-      <p:sp>
-        <p:nvSpPr>
-          <p:cNvPr id="4" name="Rounded Rectangle 3"/>
+              <a:defRPr sz="1450">
+                <a:solidFill>
+                  <a:srgbClr val="576361"/>
+                </a:solidFill>
+              </a:defRPr>
+            </a:pPr>
+            <a:r>
+              <a:t>“Turning unstructured human distress into coordinated real-world medical action in under 40 seconds.”</a:t>
+            </a:r>
+          </a:p>
+        </p:txBody>
+      </p:sp>
+      <p:pic>
+        <p:nvPicPr>
+          <p:cNvPr id="4" name="Picture 3" descr="logo.jpg"/>
+          <p:cNvPicPr>
+            <a:picLocks noChangeAspect="1"/>
+          </p:cNvPicPr>
+          <p:nvPr/>
+        </p:nvPicPr>
+        <p:blipFill>
+          <a:blip r:embed="rId2"/>
+          <a:stretch>
+            <a:fillRect/>
+          </a:stretch>
+        </p:blipFill>
+        <p:spPr>
+          <a:xfrm>
+            <a:off x="5546750" y="960120"/>
+            <a:ext cx="1097280" cy="1097280"/>
+          </a:xfrm>
+          <a:prstGeom prst="rect">
+            <a:avLst/>
+          </a:prstGeom>
+        </p:spPr>
+      </p:pic>
+      <p:sp>
+        <p:nvSpPr>
+          <p:cNvPr id="5" name="Rounded Rectangle 4"/>
           <p:cNvSpPr/>
           <p:nvPr/>
         </p:nvSpPr>
         <p:spPr>
           <a:xfrm>
-            <a:off x="1645920" y="4937760"/>
-            <a:ext cx="2011680" cy="548640"/>
+            <a:off x="1645920" y="5212080"/>
+            <a:ext cx="2103120" cy="502920"/>
           </a:xfrm>
           <a:prstGeom prst="roundRect">
             <a:avLst/>
           </a:prstGeom>
           <a:solidFill>
-            <a:srgbClr val="0D3B33"/>
+            <a:srgbClr val="FFFFFF"/>
           </a:solidFill>
-          <a:ln w="19050">
+          <a:ln w="15240">
             <a:solidFill>
-              <a:srgbClr val="10B981"/>
+              <a:srgbClr val="E8E6DF"/>
             </a:solidFill>
           </a:ln>
         </p:spPr>
@@ -3286,38 +3309,38 @@
           <a:lstStyle/>
           <a:p>
             <a:pPr algn="ctr">
-              <a:defRPr b="1" sz="1200">
-                <a:solidFill>
-                  <a:srgbClr val="FFFFFF"/>
-                </a:solidFill>
-              </a:defRPr>
-            </a:pPr>
-            <a:r>
-              <a:t>🤖 Gemini AI Triage</a:t>
-            </a:r>
-          </a:p>
-        </p:txBody>
-      </p:sp>
-      <p:sp>
-        <p:nvSpPr>
-          <p:cNvPr id="5" name="Rounded Rectangle 4"/>
+              <a:defRPr b="1" sz="1050">
+                <a:solidFill>
+                  <a:srgbClr val="005448"/>
+                </a:solidFill>
+              </a:defRPr>
+            </a:pPr>
+            <a:r>
+              <a:t>🤖 Multilingual Voice &amp; AI Triage</a:t>
+            </a:r>
+          </a:p>
+        </p:txBody>
+      </p:sp>
+      <p:sp>
+        <p:nvSpPr>
+          <p:cNvPr id="6" name="Rounded Rectangle 5"/>
           <p:cNvSpPr/>
           <p:nvPr/>
         </p:nvSpPr>
         <p:spPr>
           <a:xfrm>
-            <a:off x="3931920" y="4937760"/>
-            <a:ext cx="2103120" cy="548640"/>
+            <a:off x="3977639" y="5212080"/>
+            <a:ext cx="2011680" cy="502920"/>
           </a:xfrm>
           <a:prstGeom prst="roundRect">
             <a:avLst/>
           </a:prstGeom>
           <a:solidFill>
-            <a:srgbClr val="0D3B33"/>
+            <a:srgbClr val="FFFFFF"/>
           </a:solidFill>
-          <a:ln w="19050">
+          <a:ln w="15240">
             <a:solidFill>
-              <a:srgbClr val="10B981"/>
+              <a:srgbClr val="E8E6DF"/>
             </a:solidFill>
           </a:ln>
         </p:spPr>
@@ -3340,38 +3363,38 @@
           <a:lstStyle/>
           <a:p>
             <a:pPr algn="ctr">
-              <a:defRPr b="1" sz="1200">
-                <a:solidFill>
-                  <a:srgbClr val="FFFFFF"/>
-                </a:solidFill>
-              </a:defRPr>
-            </a:pPr>
-            <a:r>
-              <a:t>🚨 Deterministic SOS</a:t>
-            </a:r>
-          </a:p>
-        </p:txBody>
-      </p:sp>
-      <p:sp>
-        <p:nvSpPr>
-          <p:cNvPr id="6" name="Rounded Rectangle 5"/>
+              <a:defRPr b="1" sz="1050">
+                <a:solidFill>
+                  <a:srgbClr val="005448"/>
+                </a:solidFill>
+              </a:defRPr>
+            </a:pPr>
+            <a:r>
+              <a:t>🚨 Deterministic 108 SOS</a:t>
+            </a:r>
+          </a:p>
+        </p:txBody>
+      </p:sp>
+      <p:sp>
+        <p:nvSpPr>
+          <p:cNvPr id="7" name="Rounded Rectangle 6"/>
           <p:cNvSpPr/>
           <p:nvPr/>
         </p:nvSpPr>
         <p:spPr>
           <a:xfrm>
-            <a:off x="6309360" y="4937760"/>
-            <a:ext cx="2194560" cy="548640"/>
+            <a:off x="6217920" y="5212080"/>
+            <a:ext cx="2148840" cy="502920"/>
           </a:xfrm>
           <a:prstGeom prst="roundRect">
             <a:avLst/>
           </a:prstGeom>
           <a:solidFill>
-            <a:srgbClr val="0D3B33"/>
+            <a:srgbClr val="FFFFFF"/>
           </a:solidFill>
-          <a:ln w="19050">
+          <a:ln w="15240">
             <a:solidFill>
-              <a:srgbClr val="10B981"/>
+              <a:srgbClr val="E8E6DF"/>
             </a:solidFill>
           </a:ln>
         </p:spPr>
@@ -3394,38 +3417,38 @@
           <a:lstStyle/>
           <a:p>
             <a:pPr algn="ctr">
-              <a:defRPr b="1" sz="1200">
-                <a:solidFill>
-                  <a:srgbClr val="FFFFFF"/>
-                </a:solidFill>
-              </a:defRPr>
-            </a:pPr>
-            <a:r>
-              <a:t>🤝 Verified Volunteers</a:t>
-            </a:r>
-          </a:p>
-        </p:txBody>
-      </p:sp>
-      <p:sp>
-        <p:nvSpPr>
-          <p:cNvPr id="7" name="Rounded Rectangle 6"/>
+              <a:defRPr b="1" sz="1050">
+                <a:solidFill>
+                  <a:srgbClr val="005448"/>
+                </a:solidFill>
+              </a:defRPr>
+            </a:pPr>
+            <a:r>
+              <a:t>🤝 Verified Volunteer Dispatch</a:t>
+            </a:r>
+          </a:p>
+        </p:txBody>
+      </p:sp>
+      <p:sp>
+        <p:nvSpPr>
+          <p:cNvPr id="8" name="Rounded Rectangle 7"/>
           <p:cNvSpPr/>
           <p:nvPr/>
         </p:nvSpPr>
         <p:spPr>
           <a:xfrm>
-            <a:off x="8778240" y="4937760"/>
-            <a:ext cx="2011680" cy="548640"/>
+            <a:off x="8595360" y="5212080"/>
+            <a:ext cx="2103120" cy="502920"/>
           </a:xfrm>
           <a:prstGeom prst="roundRect">
             <a:avLst/>
           </a:prstGeom>
           <a:solidFill>
-            <a:srgbClr val="0D3B33"/>
+            <a:srgbClr val="FFFFFF"/>
           </a:solidFill>
-          <a:ln w="19050">
+          <a:ln w="15240">
             <a:solidFill>
-              <a:srgbClr val="10B981"/>
+              <a:srgbClr val="E8E6DF"/>
             </a:solidFill>
           </a:ln>
         </p:spPr>
@@ -3448,14 +3471,14 @@
           <a:lstStyle/>
           <a:p>
             <a:pPr algn="ctr">
-              <a:defRPr b="1" sz="1200">
-                <a:solidFill>
-                  <a:srgbClr val="FFFFFF"/>
-                </a:solidFill>
-              </a:defRPr>
-            </a:pPr>
-            <a:r>
-              <a:t>💊 Med Adherence</a:t>
+              <a:defRPr b="1" sz="1050">
+                <a:solidFill>
+                  <a:srgbClr val="005448"/>
+                </a:solidFill>
+              </a:defRPr>
+            </a:pPr>
+            <a:r>
+              <a:t>💊 Smart Prescription Adherence</a:t>
             </a:r>
           </a:p>
         </p:txBody>
@@ -3493,7 +3516,7 @@
             <a:avLst/>
           </a:prstGeom>
           <a:solidFill>
-            <a:srgbClr val="0B1413"/>
+            <a:srgbClr val="FBFAF6"/>
           </a:solidFill>
           <a:ln>
             <a:noFill/>
@@ -3529,7 +3552,7 @@
         </p:nvSpPr>
         <p:spPr>
           <a:xfrm>
-            <a:off x="731520" y="457200"/>
+            <a:off x="731520" y="411480"/>
             <a:ext cx="10728655" cy="1097280"/>
           </a:xfrm>
           <a:prstGeom prst="rect">
@@ -3545,28 +3568,28 @@
           <a:p>
             <a:pPr>
               <a:spcAft>
-                <a:spcPts val="400"/>
+                <a:spcPts val="300"/>
               </a:spcAft>
               <a:defRPr b="1" sz="1100">
                 <a:solidFill>
-                  <a:srgbClr val="EF4444"/>
-                </a:solidFill>
-              </a:defRPr>
-            </a:pPr>
-            <a:r>
-              <a:t>THE CRISIS</a:t>
-            </a:r>
-          </a:p>
-          <a:p>
-            <a:pPr>
-              <a:defRPr b="1" sz="2800">
-                <a:solidFill>
-                  <a:srgbClr val="FFFFFF"/>
-                </a:solidFill>
-              </a:defRPr>
-            </a:pPr>
-            <a:r>
-              <a:t>Rural India's Healthcare Desert</a:t>
+                  <a:srgbClr val="D62828"/>
+                </a:solidFill>
+              </a:defRPr>
+            </a:pPr>
+            <a:r>
+              <a:t>THE CRISIS &amp; RURAL REALITY</a:t>
+            </a:r>
+          </a:p>
+          <a:p>
+            <a:pPr>
+              <a:defRPr b="1" sz="2600">
+                <a:solidFill>
+                  <a:srgbClr val="121E1C"/>
+                </a:solidFill>
+              </a:defRPr>
+            </a:pPr>
+            <a:r>
+              <a:t>The 40-Kilometer Healthcare Desert</a:t>
             </a:r>
           </a:p>
         </p:txBody>
@@ -3579,18 +3602,18 @@
         </p:nvSpPr>
         <p:spPr>
           <a:xfrm>
-            <a:off x="731520" y="1737360"/>
-            <a:ext cx="3413455" cy="2103120"/>
+            <a:off x="731520" y="1645920"/>
+            <a:ext cx="3413455" cy="2011680"/>
           </a:xfrm>
           <a:prstGeom prst="roundRect">
             <a:avLst/>
           </a:prstGeom>
           <a:solidFill>
-            <a:srgbClr val="2D1212"/>
+            <a:srgbClr val="FFFFFF"/>
           </a:solidFill>
-          <a:ln w="19050">
+          <a:ln w="15240">
             <a:solidFill>
-              <a:srgbClr val="EF4444"/>
+              <a:srgbClr val="E8E6DF"/>
             </a:solidFill>
           </a:ln>
         </p:spPr>
@@ -3616,9 +3639,9 @@
               <a:spcAft>
                 <a:spcPts val="200"/>
               </a:spcAft>
-              <a:defRPr b="1" sz="3600">
-                <a:solidFill>
-                  <a:srgbClr val="EF4444"/>
+              <a:defRPr b="1" sz="3400">
+                <a:solidFill>
+                  <a:srgbClr val="D62828"/>
                 </a:solidFill>
               </a:defRPr>
             </a:pPr>
@@ -3631,9 +3654,9 @@
               <a:spcAft>
                 <a:spcPts val="400"/>
               </a:spcAft>
-              <a:defRPr b="1" sz="1400">
-                <a:solidFill>
-                  <a:srgbClr val="FFFFFF"/>
+              <a:defRPr b="1" sz="1300">
+                <a:solidFill>
+                  <a:srgbClr val="121E1C"/>
                 </a:solidFill>
               </a:defRPr>
             </a:pPr>
@@ -3643,14 +3666,14 @@
           </a:p>
           <a:p>
             <a:pPr>
-              <a:defRPr sz="1100">
-                <a:solidFill>
-                  <a:srgbClr val="A0AFAA"/>
-                </a:solidFill>
-              </a:defRPr>
-            </a:pPr>
-            <a:r>
-              <a:t>Over 650M citizens reside in rural districts with access to &lt;30% of critical healthcare infrastructure.</a:t>
+              <a:defRPr sz="1050">
+                <a:solidFill>
+                  <a:srgbClr val="576361"/>
+                </a:solidFill>
+              </a:defRPr>
+            </a:pPr>
+            <a:r>
+              <a:t>Over 650M Indian citizens reside in rural panchayats with access to &lt;30% of emergency healthcare resources.</a:t>
             </a:r>
           </a:p>
         </p:txBody>
@@ -3663,18 +3686,18 @@
         </p:nvSpPr>
         <p:spPr>
           <a:xfrm>
-            <a:off x="4389120" y="1737360"/>
-            <a:ext cx="3413455" cy="2103120"/>
+            <a:off x="4389120" y="1645920"/>
+            <a:ext cx="3413455" cy="2011680"/>
           </a:xfrm>
           <a:prstGeom prst="roundRect">
             <a:avLst/>
           </a:prstGeom>
           <a:solidFill>
-            <a:srgbClr val="2D1212"/>
+            <a:srgbClr val="FFFFFF"/>
           </a:solidFill>
-          <a:ln w="19050">
+          <a:ln w="15240">
             <a:solidFill>
-              <a:srgbClr val="EF4444"/>
+              <a:srgbClr val="E8E6DF"/>
             </a:solidFill>
           </a:ln>
         </p:spPr>
@@ -3700,9 +3723,9 @@
               <a:spcAft>
                 <a:spcPts val="200"/>
               </a:spcAft>
-              <a:defRPr b="1" sz="3600">
-                <a:solidFill>
-                  <a:srgbClr val="EF4444"/>
+              <a:defRPr b="1" sz="3400">
+                <a:solidFill>
+                  <a:srgbClr val="E68A00"/>
                 </a:solidFill>
               </a:defRPr>
             </a:pPr>
@@ -3715,26 +3738,26 @@
               <a:spcAft>
                 <a:spcPts val="400"/>
               </a:spcAft>
-              <a:defRPr b="1" sz="1400">
-                <a:solidFill>
-                  <a:srgbClr val="FFFFFF"/>
-                </a:solidFill>
-              </a:defRPr>
-            </a:pPr>
-            <a:r>
-              <a:t>Emergency Delay</a:t>
-            </a:r>
-          </a:p>
-          <a:p>
-            <a:pPr>
-              <a:defRPr sz="1100">
-                <a:solidFill>
-                  <a:srgbClr val="A0AFAA"/>
-                </a:solidFill>
-              </a:defRPr>
-            </a:pPr>
-            <a:r>
-              <a:t>Average emergency ambulance response time across Tier-3 panchayats and hilly regions.</a:t>
+              <a:defRPr b="1" sz="1300">
+                <a:solidFill>
+                  <a:srgbClr val="121E1C"/>
+                </a:solidFill>
+              </a:defRPr>
+            </a:pPr>
+            <a:r>
+              <a:t>Ambulance Lag</a:t>
+            </a:r>
+          </a:p>
+          <a:p>
+            <a:pPr>
+              <a:defRPr sz="1050">
+                <a:solidFill>
+                  <a:srgbClr val="576361"/>
+                </a:solidFill>
+              </a:defRPr>
+            </a:pPr>
+            <a:r>
+              <a:t>Average emergency ambulance transit delay across Tier-3 panchayats, hilly roads, and remote settlements.</a:t>
             </a:r>
           </a:p>
         </p:txBody>
@@ -3747,18 +3770,18 @@
         </p:nvSpPr>
         <p:spPr>
           <a:xfrm>
-            <a:off x="8046720" y="1737360"/>
-            <a:ext cx="3413455" cy="2103120"/>
+            <a:off x="8046720" y="1645920"/>
+            <a:ext cx="3413455" cy="2011680"/>
           </a:xfrm>
           <a:prstGeom prst="roundRect">
             <a:avLst/>
           </a:prstGeom>
           <a:solidFill>
-            <a:srgbClr val="2D1212"/>
+            <a:srgbClr val="FFFFFF"/>
           </a:solidFill>
-          <a:ln w="19050">
+          <a:ln w="15240">
             <a:solidFill>
-              <a:srgbClr val="EF4444"/>
+              <a:srgbClr val="E8E6DF"/>
             </a:solidFill>
           </a:ln>
         </p:spPr>
@@ -3784,9 +3807,9 @@
               <a:spcAft>
                 <a:spcPts val="200"/>
               </a:spcAft>
-              <a:defRPr b="1" sz="3600">
-                <a:solidFill>
-                  <a:srgbClr val="EF4444"/>
+              <a:defRPr b="1" sz="3400">
+                <a:solidFill>
+                  <a:srgbClr val="005448"/>
                 </a:solidFill>
               </a:defRPr>
             </a:pPr>
@@ -3799,26 +3822,26 @@
               <a:spcAft>
                 <a:spcPts val="400"/>
               </a:spcAft>
-              <a:defRPr b="1" sz="1400">
-                <a:solidFill>
-                  <a:srgbClr val="FFFFFF"/>
-                </a:solidFill>
-              </a:defRPr>
-            </a:pPr>
-            <a:r>
-              <a:t>Doctor Deficit</a:t>
-            </a:r>
-          </a:p>
-          <a:p>
-            <a:pPr>
-              <a:defRPr sz="1100">
-                <a:solidFill>
-                  <a:srgbClr val="A0AFAA"/>
-                </a:solidFill>
-              </a:defRPr>
-            </a:pPr>
-            <a:r>
-              <a:t>Severe practitioner deficit in rural community clinics compared to 1:1,000 urban density.</a:t>
+              <a:defRPr b="1" sz="1300">
+                <a:solidFill>
+                  <a:srgbClr val="121E1C"/>
+                </a:solidFill>
+              </a:defRPr>
+            </a:pPr>
+            <a:r>
+              <a:t>Practitioner Deficit</a:t>
+            </a:r>
+          </a:p>
+          <a:p>
+            <a:pPr>
+              <a:defRPr sz="1050">
+                <a:solidFill>
+                  <a:srgbClr val="576361"/>
+                </a:solidFill>
+              </a:defRPr>
+            </a:pPr>
+            <a:r>
+              <a:t>Severe rural doctor-to-patient deficit in community clinics compared to WHO benchmark of 1:1,000.</a:t>
             </a:r>
           </a:p>
         </p:txBody>
@@ -3831,18 +3854,18 @@
         </p:nvSpPr>
         <p:spPr>
           <a:xfrm>
-            <a:off x="731520" y="4114800"/>
-            <a:ext cx="10728655" cy="2103120"/>
+            <a:off x="731520" y="3931920"/>
+            <a:ext cx="10728655" cy="2468880"/>
           </a:xfrm>
           <a:prstGeom prst="roundRect">
             <a:avLst/>
           </a:prstGeom>
           <a:solidFill>
-            <a:srgbClr val="14211F"/>
+            <a:srgbClr val="FFFFFF"/>
           </a:solidFill>
-          <a:ln w="19050">
+          <a:ln w="15240">
             <a:solidFill>
-              <a:srgbClr val="233734"/>
+              <a:srgbClr val="E8E6DF"/>
             </a:solidFill>
           </a:ln>
         </p:spPr>
@@ -3870,7 +3893,7 @@
               </a:spcAft>
               <a:defRPr b="1" sz="1400">
                 <a:solidFill>
-                  <a:srgbClr val="FFFFFF"/>
+                  <a:srgbClr val="121E1C"/>
                 </a:solidFill>
               </a:defRPr>
             </a:pPr>
@@ -3885,20 +3908,20 @@
               </a:spcAft>
             </a:pPr>
             <a:r>
-              <a:rPr b="1" sz="1150">
-                <a:solidFill>
-                  <a:srgbClr val="10B981"/>
+              <a:rPr b="1" sz="1100">
+                <a:solidFill>
+                  <a:srgbClr val="005448"/>
                 </a:solidFill>
               </a:rPr>
               <a:t>• Chronic Neglect: </a:t>
             </a:r>
             <a:r>
-              <a:rPr sz="1150">
-                <a:solidFill>
-                  <a:srgbClr val="A0AFAA"/>
+              <a:rPr sz="1100">
+                <a:solidFill>
+                  <a:srgbClr val="576361"/>
                 </a:solidFill>
               </a:rPr>
-              <a:t>Elderly diabetic patients miss insulin &amp; BP doses because local pharmacies are 10-15 km away.</a:t>
+              <a:t>Elderly diabetic patients miss insulin &amp; BP doses because verified pharmacies are 10-15 km away.</a:t>
             </a:r>
           </a:p>
           <a:p>
@@ -3908,20 +3931,20 @@
               </a:spcAft>
             </a:pPr>
             <a:r>
-              <a:rPr b="1" sz="1150">
-                <a:solidFill>
-                  <a:srgbClr val="10B981"/>
+              <a:rPr b="1" sz="1100">
+                <a:solidFill>
+                  <a:srgbClr val="005448"/>
                 </a:solidFill>
               </a:rPr>
               <a:t>• ASHA Isolation: </a:t>
             </a:r>
             <a:r>
-              <a:rPr sz="1150">
-                <a:solidFill>
-                  <a:srgbClr val="A0AFAA"/>
+              <a:rPr sz="1100">
+                <a:solidFill>
+                  <a:srgbClr val="576361"/>
                 </a:solidFill>
               </a:rPr>
-              <a:t>Frontline health workers face complex clinical events without instant diagnostic or triage escalation.</a:t>
+              <a:t>Frontline health workers face complex clinical events without real-time diagnostic or triage support.</a:t>
             </a:r>
           </a:p>
           <a:p>
@@ -3931,20 +3954,20 @@
               </a:spcAft>
             </a:pPr>
             <a:r>
-              <a:rPr b="1" sz="1150">
-                <a:solidFill>
-                  <a:srgbClr val="10B981"/>
+              <a:rPr b="1" sz="1100">
+                <a:solidFill>
+                  <a:srgbClr val="005448"/>
                 </a:solidFill>
               </a:rPr>
-              <a:t>• Unwitnessed Trauma: </a:t>
-            </a:r>
-            <a:r>
-              <a:rPr sz="1150">
-                <a:solidFill>
-                  <a:srgbClr val="A0AFAA"/>
+              <a:t>• Unwitnessed Emergencies: </a:t>
+            </a:r>
+            <a:r>
+              <a:rPr sz="1100">
+                <a:solidFill>
+                  <a:srgbClr val="576361"/>
                 </a:solidFill>
               </a:rPr>
-              <a:t>Falls, acute chest pains, and domestic trauma go unreported for critical hours in remote homesteads.</a:t>
+              <a:t>Falls, acute cardiac pain, and seasonal fevers go unreported for critical hours in remote households.</a:t>
             </a:r>
           </a:p>
           <a:p>
@@ -3954,20 +3977,20 @@
               </a:spcAft>
             </a:pPr>
             <a:r>
-              <a:rPr b="1" sz="1150">
-                <a:solidFill>
-                  <a:srgbClr val="10B981"/>
+              <a:rPr b="1" sz="1100">
+                <a:solidFill>
+                  <a:srgbClr val="005448"/>
                 </a:solidFill>
               </a:rPr>
-              <a:t>• Linguistic Barriers: </a:t>
-            </a:r>
-            <a:r>
-              <a:rPr sz="1150">
-                <a:solidFill>
-                  <a:srgbClr val="A0AFAA"/>
+              <a:t>• Linguistic &amp; Dialect Barriers: </a:t>
+            </a:r>
+            <a:r>
+              <a:rPr sz="1100">
+                <a:solidFill>
+                  <a:srgbClr val="576361"/>
                 </a:solidFill>
               </a:rPr>
-              <a:t>Patients unable to effectively communicate symptom histories in standardized terminology.</a:t>
+              <a:t>Patients unable to effectively communicate symptom histories in standardized English terminology.</a:t>
             </a:r>
           </a:p>
         </p:txBody>
@@ -4005,7 +4028,7 @@
             <a:avLst/>
           </a:prstGeom>
           <a:solidFill>
-            <a:srgbClr val="0B1413"/>
+            <a:srgbClr val="FBFAF6"/>
           </a:solidFill>
           <a:ln>
             <a:noFill/>
@@ -4041,7 +4064,7 @@
         </p:nvSpPr>
         <p:spPr>
           <a:xfrm>
-            <a:off x="731520" y="457200"/>
+            <a:off x="731520" y="411480"/>
             <a:ext cx="10728655" cy="1097280"/>
           </a:xfrm>
           <a:prstGeom prst="rect">
@@ -4057,28 +4080,28 @@
           <a:p>
             <a:pPr>
               <a:spcAft>
-                <a:spcPts val="400"/>
+                <a:spcPts val="300"/>
               </a:spcAft>
               <a:defRPr b="1" sz="1100">
                 <a:solidFill>
-                  <a:srgbClr val="10B981"/>
-                </a:solidFill>
-              </a:defRPr>
-            </a:pPr>
-            <a:r>
-              <a:t>THE SOLUTION</a:t>
-            </a:r>
-          </a:p>
-          <a:p>
-            <a:pPr>
-              <a:defRPr b="1" sz="2800">
-                <a:solidFill>
-                  <a:srgbClr val="FFFFFF"/>
-                </a:solidFill>
-              </a:defRPr>
-            </a:pPr>
-            <a:r>
-              <a:t>AroggyaGram: One Unified Platform, Four Pillars</a:t>
+                  <a:srgbClr val="005448"/>
+                </a:solidFill>
+              </a:defRPr>
+            </a:pPr>
+            <a:r>
+              <a:t>THE PLATFORM SOLUTION</a:t>
+            </a:r>
+          </a:p>
+          <a:p>
+            <a:pPr>
+              <a:defRPr b="1" sz="2600">
+                <a:solidFill>
+                  <a:srgbClr val="121E1C"/>
+                </a:solidFill>
+              </a:defRPr>
+            </a:pPr>
+            <a:r>
+              <a:t>AroggyaGram: One Unified Platform, Four Architectural Pillars</a:t>
             </a:r>
           </a:p>
         </p:txBody>
@@ -4091,18 +4114,252 @@
         </p:nvSpPr>
         <p:spPr>
           <a:xfrm>
-            <a:off x="731520" y="1737360"/>
+            <a:off x="731520" y="1645920"/>
+            <a:ext cx="5212080" cy="2286000"/>
+          </a:xfrm>
+          <a:prstGeom prst="roundRect">
+            <a:avLst/>
+          </a:prstGeom>
+          <a:solidFill>
+            <a:srgbClr val="FFFFFF"/>
+          </a:solidFill>
+          <a:ln w="15240">
+            <a:solidFill>
+              <a:srgbClr val="E8E6DF"/>
+            </a:solidFill>
+          </a:ln>
+        </p:spPr>
+        <p:style>
+          <a:lnRef idx="1">
+            <a:schemeClr val="accent1"/>
+          </a:lnRef>
+          <a:fillRef idx="3">
+            <a:schemeClr val="accent1"/>
+          </a:fillRef>
+          <a:effectRef idx="2">
+            <a:schemeClr val="accent1"/>
+          </a:effectRef>
+          <a:fontRef idx="minor">
+            <a:schemeClr val="lt1"/>
+          </a:fontRef>
+        </p:style>
+        <p:txBody>
+          <a:bodyPr rtlCol="0" anchor="ctr" wrap="square" lIns="228600" rIns="228600" tIns="228600" bIns="228600"/>
+          <a:lstStyle/>
+          <a:p>
+            <a:pPr algn="ctr">
+              <a:spcAft>
+                <a:spcPts val="600"/>
+              </a:spcAft>
+              <a:defRPr b="1" sz="1300">
+                <a:solidFill>
+                  <a:srgbClr val="005448"/>
+                </a:solidFill>
+              </a:defRPr>
+            </a:pPr>
+            <a:r>
+              <a:t>🤖  Clinical AI Triage (Ask Aroggya)</a:t>
+            </a:r>
+          </a:p>
+          <a:p>
+            <a:pPr>
+              <a:spcAft>
+                <a:spcPts val="200"/>
+              </a:spcAft>
+              <a:defRPr sz="1050">
+                <a:solidFill>
+                  <a:srgbClr val="576361"/>
+                </a:solidFill>
+              </a:defRPr>
+            </a:pPr>
+            <a:r>
+              <a:t>• Powered by Google Gemini 2.5 Flash + Clinical Safety Rules</a:t>
+            </a:r>
+          </a:p>
+          <a:p>
+            <a:pPr>
+              <a:spcAft>
+                <a:spcPts val="200"/>
+              </a:spcAft>
+              <a:defRPr sz="1050">
+                <a:solidFill>
+                  <a:srgbClr val="576361"/>
+                </a:solidFill>
+              </a:defRPr>
+            </a:pPr>
+            <a:r>
+              <a:t>• Native voice-to-text in Malayalam, Hindi &amp; English via Capacitor</a:t>
+            </a:r>
+          </a:p>
+          <a:p>
+            <a:pPr>
+              <a:spcAft>
+                <a:spcPts val="200"/>
+              </a:spcAft>
+              <a:defRPr sz="1050">
+                <a:solidFill>
+                  <a:srgbClr val="576361"/>
+                </a:solidFill>
+              </a:defRPr>
+            </a:pPr>
+            <a:r>
+              <a:t>• Categorizes symptoms: LOW, MODERATE, HIGH, CRITICAL</a:t>
+            </a:r>
+          </a:p>
+          <a:p>
+            <a:pPr>
+              <a:spcAft>
+                <a:spcPts val="200"/>
+              </a:spcAft>
+              <a:defRPr sz="1050">
+                <a:solidFill>
+                  <a:srgbClr val="576361"/>
+                </a:solidFill>
+              </a:defRPr>
+            </a:pPr>
+            <a:r>
+              <a:t>• Zero-overlap floating input card + automatic reading scroll</a:t>
+            </a:r>
+          </a:p>
+        </p:txBody>
+      </p:sp>
+      <p:sp>
+        <p:nvSpPr>
+          <p:cNvPr id="5" name="Rounded Rectangle 4"/>
+          <p:cNvSpPr/>
+          <p:nvPr/>
+        </p:nvSpPr>
+        <p:spPr>
+          <a:xfrm>
+            <a:off x="6217920" y="1645920"/>
+            <a:ext cx="5212080" cy="2286000"/>
+          </a:xfrm>
+          <a:prstGeom prst="roundRect">
+            <a:avLst/>
+          </a:prstGeom>
+          <a:solidFill>
+            <a:srgbClr val="FFFFFF"/>
+          </a:solidFill>
+          <a:ln w="15240">
+            <a:solidFill>
+              <a:srgbClr val="E8E6DF"/>
+            </a:solidFill>
+          </a:ln>
+        </p:spPr>
+        <p:style>
+          <a:lnRef idx="1">
+            <a:schemeClr val="accent1"/>
+          </a:lnRef>
+          <a:fillRef idx="3">
+            <a:schemeClr val="accent1"/>
+          </a:fillRef>
+          <a:effectRef idx="2">
+            <a:schemeClr val="accent1"/>
+          </a:effectRef>
+          <a:fontRef idx="minor">
+            <a:schemeClr val="lt1"/>
+          </a:fontRef>
+        </p:style>
+        <p:txBody>
+          <a:bodyPr rtlCol="0" anchor="ctr" wrap="square" lIns="228600" rIns="228600" tIns="228600" bIns="228600"/>
+          <a:lstStyle/>
+          <a:p>
+            <a:pPr algn="ctr">
+              <a:spcAft>
+                <a:spcPts val="600"/>
+              </a:spcAft>
+              <a:defRPr b="1" sz="1300">
+                <a:solidFill>
+                  <a:srgbClr val="D62828"/>
+                </a:solidFill>
+              </a:defRPr>
+            </a:pPr>
+            <a:r>
+              <a:t>🚨  Deterministic Emergency SOS</a:t>
+            </a:r>
+          </a:p>
+          <a:p>
+            <a:pPr>
+              <a:spcAft>
+                <a:spcPts val="200"/>
+              </a:spcAft>
+              <a:defRPr sz="1050">
+                <a:solidFill>
+                  <a:srgbClr val="576361"/>
+                </a:solidFill>
+              </a:defRPr>
+            </a:pPr>
+            <a:r>
+              <a:t>• Automatic red-flag detection bypasses AI for immediate rescue</a:t>
+            </a:r>
+          </a:p>
+          <a:p>
+            <a:pPr>
+              <a:spcAft>
+                <a:spcPts val="200"/>
+              </a:spcAft>
+              <a:defRPr sz="1050">
+                <a:solidFill>
+                  <a:srgbClr val="576361"/>
+                </a:solidFill>
+              </a:defRPr>
+            </a:pPr>
+            <a:r>
+              <a:t>• 1-Tap emergency dial directly to 9539141210 / 108 Ambulance</a:t>
+            </a:r>
+          </a:p>
+          <a:p>
+            <a:pPr>
+              <a:spcAft>
+                <a:spcPts val="200"/>
+              </a:spcAft>
+              <a:defRPr sz="1050">
+                <a:solidFill>
+                  <a:srgbClr val="576361"/>
+                </a:solidFill>
+              </a:defRPr>
+            </a:pPr>
+            <a:r>
+              <a:t>• High-precision GPS coordinates + reverse geo-tagged address</a:t>
+            </a:r>
+          </a:p>
+          <a:p>
+            <a:pPr>
+              <a:spcAft>
+                <a:spcPts val="200"/>
+              </a:spcAft>
+              <a:defRPr sz="1050">
+                <a:solidFill>
+                  <a:srgbClr val="576361"/>
+                </a:solidFill>
+              </a:defRPr>
+            </a:pPr>
+            <a:r>
+              <a:t>• Caregiver dispatch notifications with live status tracking</a:t>
+            </a:r>
+          </a:p>
+        </p:txBody>
+      </p:sp>
+      <p:sp>
+        <p:nvSpPr>
+          <p:cNvPr id="6" name="Rounded Rectangle 5"/>
+          <p:cNvSpPr/>
+          <p:nvPr/>
+        </p:nvSpPr>
+        <p:spPr>
+          <a:xfrm>
+            <a:off x="731520" y="4206240"/>
             <a:ext cx="5212080" cy="2194560"/>
           </a:xfrm>
           <a:prstGeom prst="roundRect">
             <a:avLst/>
           </a:prstGeom>
           <a:solidFill>
-            <a:srgbClr val="0D3B33"/>
+            <a:srgbClr val="FFFFFF"/>
           </a:solidFill>
-          <a:ln w="19050">
+          <a:ln w="15240">
             <a:solidFill>
-              <a:srgbClr val="10B981"/>
+              <a:srgbClr val="E8E6DF"/>
             </a:solidFill>
           </a:ln>
         </p:spPr>
@@ -4128,14 +4385,14 @@
               <a:spcAft>
                 <a:spcPts val="600"/>
               </a:spcAft>
-              <a:defRPr b="1" sz="1400">
-                <a:solidFill>
-                  <a:srgbClr val="FFFFFF"/>
-                </a:solidFill>
-              </a:defRPr>
-            </a:pPr>
-            <a:r>
-              <a:t>🤖  AI Clinical Triage (Ask Aroggya)</a:t>
+              <a:defRPr b="1" sz="1300">
+                <a:solidFill>
+                  <a:srgbClr val="2563EB"/>
+                </a:solidFill>
+              </a:defRPr>
+            </a:pPr>
+            <a:r>
+              <a:t>🤝  Volunteer Task &amp; Responder Network</a:t>
             </a:r>
           </a:p>
           <a:p>
@@ -4143,14 +4400,14 @@
               <a:spcAft>
                 <a:spcPts val="200"/>
               </a:spcAft>
-              <a:defRPr sz="1100">
-                <a:solidFill>
-                  <a:srgbClr val="FBFAF6"/>
-                </a:solidFill>
-              </a:defRPr>
-            </a:pPr>
-            <a:r>
-              <a:t>• Powered by Google Gemini 2.5 Flash</a:t>
+              <a:defRPr sz="1050">
+                <a:solidFill>
+                  <a:srgbClr val="576361"/>
+                </a:solidFill>
+              </a:defRPr>
+            </a:pPr>
+            <a:r>
+              <a:t>• Mobilizes verified local neighbors for high-impact care tasks</a:t>
             </a:r>
           </a:p>
           <a:p>
@@ -4158,14 +4415,14 @@
               <a:spcAft>
                 <a:spcPts val="200"/>
               </a:spcAft>
-              <a:defRPr sz="1100">
-                <a:solidFill>
-                  <a:srgbClr val="FBFAF6"/>
-                </a:solidFill>
-              </a:defRPr>
-            </a:pPr>
-            <a:r>
-              <a:t>• Natural speech/text in Malayalam, Hindi, Tamil, Bengali &amp; English</a:t>
+              <a:defRPr sz="1050">
+                <a:solidFill>
+                  <a:srgbClr val="576361"/>
+                </a:solidFill>
+              </a:defRPr>
+            </a:pPr>
+            <a:r>
+              <a:t>• 100-Point algorithmic matching (distance, skills, rating, vehicle)</a:t>
             </a:r>
           </a:p>
           <a:p>
@@ -4173,14 +4430,14 @@
               <a:spcAft>
                 <a:spcPts val="200"/>
               </a:spcAft>
-              <a:defRPr sz="1100">
-                <a:solidFill>
-                  <a:srgbClr val="FBFAF6"/>
-                </a:solidFill>
-              </a:defRPr>
-            </a:pPr>
-            <a:r>
-              <a:t>• Evaluates symptoms into LOW, MEDIUM, HIGH, CRITICAL risks</a:t>
+              <a:defRPr sz="1050">
+                <a:solidFill>
+                  <a:srgbClr val="576361"/>
+                </a:solidFill>
+              </a:defRPr>
+            </a:pPr>
+            <a:r>
+              <a:t>• Interactive geospatial map view for active community assistance</a:t>
             </a:r>
           </a:p>
           <a:p>
@@ -4188,38 +4445,38 @@
               <a:spcAft>
                 <a:spcPts val="200"/>
               </a:spcAft>
-              <a:defRPr sz="1100">
-                <a:solidFill>
-                  <a:srgbClr val="FBFAF6"/>
-                </a:solidFill>
-              </a:defRPr>
-            </a:pPr>
-            <a:r>
-              <a:t>• Immediate first-aid and clinic referral protocols (zero delays)</a:t>
-            </a:r>
-          </a:p>
-        </p:txBody>
-      </p:sp>
-      <p:sp>
-        <p:nvSpPr>
-          <p:cNvPr id="5" name="Rounded Rectangle 4"/>
+              <a:defRPr sz="1050">
+                <a:solidFill>
+                  <a:srgbClr val="576361"/>
+                </a:solidFill>
+              </a:defRPr>
+            </a:pPr>
+            <a:r>
+              <a:t>• Scoped non-clinical tasks: medicine pickup, hospital escort</a:t>
+            </a:r>
+          </a:p>
+        </p:txBody>
+      </p:sp>
+      <p:sp>
+        <p:nvSpPr>
+          <p:cNvPr id="7" name="Rounded Rectangle 6"/>
           <p:cNvSpPr/>
           <p:nvPr/>
         </p:nvSpPr>
         <p:spPr>
           <a:xfrm>
-            <a:off x="6217920" y="1737360"/>
+            <a:off x="6217920" y="4206240"/>
             <a:ext cx="5212080" cy="2194560"/>
           </a:xfrm>
           <a:prstGeom prst="roundRect">
             <a:avLst/>
           </a:prstGeom>
           <a:solidFill>
-            <a:srgbClr val="2D1212"/>
+            <a:srgbClr val="FFFFFF"/>
           </a:solidFill>
-          <a:ln w="19050">
+          <a:ln w="15240">
             <a:solidFill>
-              <a:srgbClr val="EF4444"/>
+              <a:srgbClr val="E8E6DF"/>
             </a:solidFill>
           </a:ln>
         </p:spPr>
@@ -4245,14 +4502,14 @@
               <a:spcAft>
                 <a:spcPts val="600"/>
               </a:spcAft>
-              <a:defRPr b="1" sz="1400">
-                <a:solidFill>
-                  <a:srgbClr val="FFFFFF"/>
-                </a:solidFill>
-              </a:defRPr>
-            </a:pPr>
-            <a:r>
-              <a:t>🚨  Deterministic Emergency SOS</a:t>
+              <a:defRPr b="1" sz="1300">
+                <a:solidFill>
+                  <a:srgbClr val="7C3AED"/>
+                </a:solidFill>
+              </a:defRPr>
+            </a:pPr>
+            <a:r>
+              <a:t>💊  Structured Medication Adherence</a:t>
             </a:r>
           </a:p>
           <a:p>
@@ -4260,14 +4517,14 @@
               <a:spcAft>
                 <a:spcPts val="200"/>
               </a:spcAft>
-              <a:defRPr sz="1100">
-                <a:solidFill>
-                  <a:srgbClr val="FBFAF6"/>
-                </a:solidFill>
-              </a:defRPr>
-            </a:pPr>
-            <a:r>
-              <a:t>• Automatic keyword detection bypasses AI for immediate rescue</a:t>
+              <a:defRPr sz="1050">
+                <a:solidFill>
+                  <a:srgbClr val="576361"/>
+                </a:solidFill>
+              </a:defRPr>
+            </a:pPr>
+            <a:r>
+              <a:t>• Replaces forgotten paper prescriptions with digital schedules</a:t>
             </a:r>
           </a:p>
           <a:p>
@@ -4275,14 +4532,14 @@
               <a:spcAft>
                 <a:spcPts val="200"/>
               </a:spcAft>
-              <a:defRPr sz="1100">
-                <a:solidFill>
-                  <a:srgbClr val="FBFAF6"/>
-                </a:solidFill>
-              </a:defRPr>
-            </a:pPr>
-            <a:r>
-              <a:t>• 1-Tap emergency dial directly to 9539141210</a:t>
+              <a:defRPr sz="1050">
+                <a:solidFill>
+                  <a:srgbClr val="576361"/>
+                </a:solidFill>
+              </a:defRPr>
+            </a:pPr>
+            <a:r>
+              <a:t>• Dosage tracker: tablets, syrups, strength &amp; meal relations</a:t>
             </a:r>
           </a:p>
           <a:p>
@@ -4290,14 +4547,14 @@
               <a:spcAft>
                 <a:spcPts val="200"/>
               </a:spcAft>
-              <a:defRPr sz="1100">
-                <a:solidFill>
-                  <a:srgbClr val="FBFAF6"/>
-                </a:solidFill>
-              </a:defRPr>
-            </a:pPr>
-            <a:r>
-              <a:t>• Instant GPS coordinate capture with reverse geo-tagging</a:t>
+              <a:defRPr sz="1050">
+                <a:solidFill>
+                  <a:srgbClr val="576361"/>
+                </a:solidFill>
+              </a:defRPr>
+            </a:pPr>
+            <a:r>
+              <a:t>• Native 24h clock selector + fast mealtime presets (M/N/E)</a:t>
             </a:r>
           </a:p>
           <a:p>
@@ -4305,248 +4562,14 @@
               <a:spcAft>
                 <a:spcPts val="200"/>
               </a:spcAft>
-              <a:defRPr sz="1100">
-                <a:solidFill>
-                  <a:srgbClr val="FBFAF6"/>
-                </a:solidFill>
-              </a:defRPr>
-            </a:pPr>
-            <a:r>
-              <a:t>• Multi-recipient WhatsApp emergency alerts to designated family</a:t>
-            </a:r>
-          </a:p>
-        </p:txBody>
-      </p:sp>
-      <p:sp>
-        <p:nvSpPr>
-          <p:cNvPr id="6" name="Rounded Rectangle 5"/>
-          <p:cNvSpPr/>
-          <p:nvPr/>
-        </p:nvSpPr>
-        <p:spPr>
-          <a:xfrm>
-            <a:off x="731520" y="4206240"/>
-            <a:ext cx="5212080" cy="2103120"/>
-          </a:xfrm>
-          <a:prstGeom prst="roundRect">
-            <a:avLst/>
-          </a:prstGeom>
-          <a:solidFill>
-            <a:srgbClr val="0F203A"/>
-          </a:solidFill>
-          <a:ln w="19050">
-            <a:solidFill>
-              <a:srgbClr val="3B82F6"/>
-            </a:solidFill>
-          </a:ln>
-        </p:spPr>
-        <p:style>
-          <a:lnRef idx="1">
-            <a:schemeClr val="accent1"/>
-          </a:lnRef>
-          <a:fillRef idx="3">
-            <a:schemeClr val="accent1"/>
-          </a:fillRef>
-          <a:effectRef idx="2">
-            <a:schemeClr val="accent1"/>
-          </a:effectRef>
-          <a:fontRef idx="minor">
-            <a:schemeClr val="lt1"/>
-          </a:fontRef>
-        </p:style>
-        <p:txBody>
-          <a:bodyPr rtlCol="0" anchor="ctr" wrap="square" lIns="228600" rIns="228600" tIns="228600" bIns="228600"/>
-          <a:lstStyle/>
-          <a:p>
-            <a:pPr algn="ctr">
-              <a:spcAft>
-                <a:spcPts val="600"/>
-              </a:spcAft>
-              <a:defRPr b="1" sz="1400">
-                <a:solidFill>
-                  <a:srgbClr val="FFFFFF"/>
-                </a:solidFill>
-              </a:defRPr>
-            </a:pPr>
-            <a:r>
-              <a:t>🤝  Volunteer Task &amp; Responder Network</a:t>
-            </a:r>
-          </a:p>
-          <a:p>
-            <a:pPr>
-              <a:spcAft>
-                <a:spcPts val="200"/>
-              </a:spcAft>
-              <a:defRPr sz="1100">
-                <a:solidFill>
-                  <a:srgbClr val="FBFAF6"/>
-                </a:solidFill>
-              </a:defRPr>
-            </a:pPr>
-            <a:r>
-              <a:t>• Mobilizes verified local neighbors for high-impact care tasks</a:t>
-            </a:r>
-          </a:p>
-          <a:p>
-            <a:pPr>
-              <a:spcAft>
-                <a:spcPts val="200"/>
-              </a:spcAft>
-              <a:defRPr sz="1100">
-                <a:solidFill>
-                  <a:srgbClr val="FBFAF6"/>
-                </a:solidFill>
-              </a:defRPr>
-            </a:pPr>
-            <a:r>
-              <a:t>• 100-Point algorithmic matching (distance, skills, rating, vehicle)</a:t>
-            </a:r>
-          </a:p>
-          <a:p>
-            <a:pPr>
-              <a:spcAft>
-                <a:spcPts val="200"/>
-              </a:spcAft>
-              <a:defRPr sz="1100">
-                <a:solidFill>
-                  <a:srgbClr val="FBFAF6"/>
-                </a:solidFill>
-              </a:defRPr>
-            </a:pPr>
-            <a:r>
-              <a:t>• Interactive Leaflet map view for active and nearby assistance calls</a:t>
-            </a:r>
-          </a:p>
-          <a:p>
-            <a:pPr>
-              <a:spcAft>
-                <a:spcPts val="200"/>
-              </a:spcAft>
-              <a:defRPr sz="1100">
-                <a:solidFill>
-                  <a:srgbClr val="FBFAF6"/>
-                </a:solidFill>
-              </a:defRPr>
-            </a:pPr>
-            <a:r>
-              <a:t>• Scoped neighbor tasks: prescription pickup, clinic transport, welfare checks</a:t>
-            </a:r>
-          </a:p>
-        </p:txBody>
-      </p:sp>
-      <p:sp>
-        <p:nvSpPr>
-          <p:cNvPr id="7" name="Rounded Rectangle 6"/>
-          <p:cNvSpPr/>
-          <p:nvPr/>
-        </p:nvSpPr>
-        <p:spPr>
-          <a:xfrm>
-            <a:off x="6217920" y="4206240"/>
-            <a:ext cx="5212080" cy="2103120"/>
-          </a:xfrm>
-          <a:prstGeom prst="roundRect">
-            <a:avLst/>
-          </a:prstGeom>
-          <a:solidFill>
-            <a:srgbClr val="231230"/>
-          </a:solidFill>
-          <a:ln w="19050">
-            <a:solidFill>
-              <a:srgbClr val="A855F7"/>
-            </a:solidFill>
-          </a:ln>
-        </p:spPr>
-        <p:style>
-          <a:lnRef idx="1">
-            <a:schemeClr val="accent1"/>
-          </a:lnRef>
-          <a:fillRef idx="3">
-            <a:schemeClr val="accent1"/>
-          </a:fillRef>
-          <a:effectRef idx="2">
-            <a:schemeClr val="accent1"/>
-          </a:effectRef>
-          <a:fontRef idx="minor">
-            <a:schemeClr val="lt1"/>
-          </a:fontRef>
-        </p:style>
-        <p:txBody>
-          <a:bodyPr rtlCol="0" anchor="ctr" wrap="square" lIns="228600" rIns="228600" tIns="228600" bIns="228600"/>
-          <a:lstStyle/>
-          <a:p>
-            <a:pPr algn="ctr">
-              <a:spcAft>
-                <a:spcPts val="600"/>
-              </a:spcAft>
-              <a:defRPr b="1" sz="1400">
-                <a:solidFill>
-                  <a:srgbClr val="FFFFFF"/>
-                </a:solidFill>
-              </a:defRPr>
-            </a:pPr>
-            <a:r>
-              <a:t>💊  Structured Medication Adherence</a:t>
-            </a:r>
-          </a:p>
-          <a:p>
-            <a:pPr>
-              <a:spcAft>
-                <a:spcPts val="200"/>
-              </a:spcAft>
-              <a:defRPr sz="1100">
-                <a:solidFill>
-                  <a:srgbClr val="FBFAF6"/>
-                </a:solidFill>
-              </a:defRPr>
-            </a:pPr>
-            <a:r>
-              <a:t>• Eliminates paper schedules with smart digital prescription tracking</a:t>
-            </a:r>
-          </a:p>
-          <a:p>
-            <a:pPr>
-              <a:spcAft>
-                <a:spcPts val="200"/>
-              </a:spcAft>
-              <a:defRPr sz="1100">
-                <a:solidFill>
-                  <a:srgbClr val="FBFAF6"/>
-                </a:solidFill>
-              </a:defRPr>
-            </a:pPr>
-            <a:r>
-              <a:t>• Structured dosage picker: tablets, syrups, strength &amp; food relations</a:t>
-            </a:r>
-          </a:p>
-          <a:p>
-            <a:pPr>
-              <a:spcAft>
-                <a:spcPts val="200"/>
-              </a:spcAft>
-              <a:defRPr sz="1100">
-                <a:solidFill>
-                  <a:srgbClr val="FBFAF6"/>
-                </a:solidFill>
-              </a:defRPr>
-            </a:pPr>
-            <a:r>
-              <a:t>• Native 24h clock selector + fast mealtime presets (Morning, Noon, Night)</a:t>
-            </a:r>
-          </a:p>
-          <a:p>
-            <a:pPr>
-              <a:spcAft>
-                <a:spcPts val="200"/>
-              </a:spcAft>
-              <a:defRPr sz="1100">
-                <a:solidFill>
-                  <a:srgbClr val="FBFAF6"/>
-                </a:solidFill>
-              </a:defRPr>
-            </a:pPr>
-            <a:r>
-              <a:t>• Daily compliance score &amp; proactive adherence guidance notifications</a:t>
+              <a:defRPr sz="1050">
+                <a:solidFill>
+                  <a:srgbClr val="576361"/>
+                </a:solidFill>
+              </a:defRPr>
+            </a:pPr>
+            <a:r>
+              <a:t>• Strict 10-digit phone verification &amp; Supabase cloud sync</a:t>
             </a:r>
           </a:p>
         </p:txBody>
@@ -4584,7 +4607,7 @@
             <a:avLst/>
           </a:prstGeom>
           <a:solidFill>
-            <a:srgbClr val="0B1413"/>
+            <a:srgbClr val="FBFAF6"/>
           </a:solidFill>
           <a:ln>
             <a:noFill/>
@@ -4620,7 +4643,7 @@
         </p:nvSpPr>
         <p:spPr>
           <a:xfrm>
-            <a:off x="731520" y="457200"/>
+            <a:off x="731520" y="411480"/>
             <a:ext cx="10728655" cy="1097280"/>
           </a:xfrm>
           <a:prstGeom prst="rect">
@@ -4636,11 +4659,11 @@
           <a:p>
             <a:pPr>
               <a:spcAft>
-                <a:spcPts val="400"/>
+                <a:spcPts val="300"/>
               </a:spcAft>
               <a:defRPr b="1" sz="1100">
                 <a:solidFill>
-                  <a:srgbClr val="10B981"/>
+                  <a:srgbClr val="005448"/>
                 </a:solidFill>
               </a:defRPr>
             </a:pPr>
@@ -4650,14 +4673,14 @@
           </a:p>
           <a:p>
             <a:pPr>
-              <a:defRPr b="1" sz="2800">
-                <a:solidFill>
-                  <a:srgbClr val="FFFFFF"/>
-                </a:solidFill>
-              </a:defRPr>
-            </a:pPr>
-            <a:r>
-              <a:t>From Distress Signal to Coordinated Real-World Action</a:t>
+              <a:defRPr b="1" sz="2600">
+                <a:solidFill>
+                  <a:srgbClr val="121E1C"/>
+                </a:solidFill>
+              </a:defRPr>
+            </a:pPr>
+            <a:r>
+              <a:t>From Colloquial Distress Signal to Coordinated Real-World Action</a:t>
             </a:r>
           </a:p>
         </p:txBody>
@@ -4670,18 +4693,18 @@
         </p:nvSpPr>
         <p:spPr>
           <a:xfrm>
-            <a:off x="731520" y="1737360"/>
-            <a:ext cx="2499055" cy="4480560"/>
+            <a:off x="731520" y="1645920"/>
+            <a:ext cx="2499055" cy="4663440"/>
           </a:xfrm>
           <a:prstGeom prst="roundRect">
             <a:avLst/>
           </a:prstGeom>
           <a:solidFill>
-            <a:srgbClr val="14211F"/>
+            <a:srgbClr val="FFFFFF"/>
           </a:solidFill>
-          <a:ln w="19050">
+          <a:ln w="15240">
             <a:solidFill>
-              <a:srgbClr val="10B981"/>
+              <a:srgbClr val="E8E6DF"/>
             </a:solidFill>
           </a:ln>
         </p:spPr>
@@ -4709,7 +4732,7 @@
               </a:spcAft>
               <a:defRPr b="1" sz="1200">
                 <a:solidFill>
-                  <a:srgbClr val="10B981"/>
+                  <a:srgbClr val="005448"/>
                 </a:solidFill>
               </a:defRPr>
             </a:pPr>
@@ -4722,14 +4745,14 @@
               <a:spcAft>
                 <a:spcPts val="1200"/>
               </a:spcAft>
-              <a:defRPr b="1" sz="1600">
-                <a:solidFill>
-                  <a:srgbClr val="FFFFFF"/>
-                </a:solidFill>
-              </a:defRPr>
-            </a:pPr>
-            <a:r>
-              <a:t>Voice / Text Intake</a:t>
+              <a:defRPr b="1" sz="1500">
+                <a:solidFill>
+                  <a:srgbClr val="121E1C"/>
+                </a:solidFill>
+              </a:defRPr>
+            </a:pPr>
+            <a:r>
+              <a:t>Native Voice / Dialect Intake</a:t>
             </a:r>
           </a:p>
           <a:p>
@@ -4737,14 +4760,14 @@
               <a:spcAft>
                 <a:spcPts val="400"/>
               </a:spcAft>
-              <a:defRPr sz="1150">
-                <a:solidFill>
-                  <a:srgbClr val="A0AFAA"/>
-                </a:solidFill>
-              </a:defRPr>
-            </a:pPr>
-            <a:r>
-              <a:t>Citizen speaks in dialect or types raw symptoms.</a:t>
+              <a:defRPr sz="1100">
+                <a:solidFill>
+                  <a:srgbClr val="576361"/>
+                </a:solidFill>
+              </a:defRPr>
+            </a:pPr>
+            <a:r>
+              <a:t>Citizen speaks naturally or types symptoms.</a:t>
             </a:r>
           </a:p>
           <a:p>
@@ -4752,14 +4775,14 @@
               <a:spcAft>
                 <a:spcPts val="400"/>
               </a:spcAft>
-              <a:defRPr sz="1150">
-                <a:solidFill>
-                  <a:srgbClr val="A0AFAA"/>
-                </a:solidFill>
-              </a:defRPr>
-            </a:pPr>
-            <a:r>
-              <a:t>Web Speech API captures voice stream;</a:t>
+              <a:defRPr sz="1100">
+                <a:solidFill>
+                  <a:srgbClr val="576361"/>
+                </a:solidFill>
+              </a:defRPr>
+            </a:pPr>
+            <a:r>
+              <a:t>Offline-ready Android speech recognition captures transcript;</a:t>
             </a:r>
           </a:p>
           <a:p>
@@ -4767,14 +4790,14 @@
               <a:spcAft>
                 <a:spcPts val="400"/>
               </a:spcAft>
-              <a:defRPr sz="1150">
-                <a:solidFill>
-                  <a:srgbClr val="A0AFAA"/>
-                </a:solidFill>
-              </a:defRPr>
-            </a:pPr>
-            <a:r>
-              <a:t>zero complex medical jargon required.</a:t>
+              <a:defRPr sz="1100">
+                <a:solidFill>
+                  <a:srgbClr val="576361"/>
+                </a:solidFill>
+              </a:defRPr>
+            </a:pPr>
+            <a:r>
+              <a:t>zero medical terminology required.</a:t>
             </a:r>
           </a:p>
         </p:txBody>
@@ -4787,18 +4810,18 @@
         </p:nvSpPr>
         <p:spPr>
           <a:xfrm>
-            <a:off x="3474720" y="1737360"/>
-            <a:ext cx="2499055" cy="4480560"/>
+            <a:off x="3474720" y="1645920"/>
+            <a:ext cx="2499055" cy="4663440"/>
           </a:xfrm>
           <a:prstGeom prst="roundRect">
             <a:avLst/>
           </a:prstGeom>
           <a:solidFill>
-            <a:srgbClr val="14211F"/>
+            <a:srgbClr val="FFFFFF"/>
           </a:solidFill>
-          <a:ln w="19050">
+          <a:ln w="15240">
             <a:solidFill>
-              <a:srgbClr val="F59E0B"/>
+              <a:srgbClr val="E8E6DF"/>
             </a:solidFill>
           </a:ln>
         </p:spPr>
@@ -4826,7 +4849,7 @@
               </a:spcAft>
               <a:defRPr b="1" sz="1200">
                 <a:solidFill>
-                  <a:srgbClr val="F59E0B"/>
+                  <a:srgbClr val="E68A00"/>
                 </a:solidFill>
               </a:defRPr>
             </a:pPr>
@@ -4839,14 +4862,14 @@
               <a:spcAft>
                 <a:spcPts val="1200"/>
               </a:spcAft>
-              <a:defRPr b="1" sz="1600">
-                <a:solidFill>
-                  <a:srgbClr val="FFFFFF"/>
-                </a:solidFill>
-              </a:defRPr>
-            </a:pPr>
-            <a:r>
-              <a:t>AI Situation Engine</a:t>
+              <a:defRPr b="1" sz="1500">
+                <a:solidFill>
+                  <a:srgbClr val="121E1C"/>
+                </a:solidFill>
+              </a:defRPr>
+            </a:pPr>
+            <a:r>
+              <a:t>Situation &amp; Safety Engine</a:t>
             </a:r>
           </a:p>
           <a:p>
@@ -4854,14 +4877,14 @@
               <a:spcAft>
                 <a:spcPts val="400"/>
               </a:spcAft>
-              <a:defRPr sz="1150">
-                <a:solidFill>
-                  <a:srgbClr val="A0AFAA"/>
-                </a:solidFill>
-              </a:defRPr>
-            </a:pPr>
-            <a:r>
-              <a:t>Gemini triages distress severity.</a:t>
+              <a:defRPr sz="1100">
+                <a:solidFill>
+                  <a:srgbClr val="576361"/>
+                </a:solidFill>
+              </a:defRPr>
+            </a:pPr>
+            <a:r>
+              <a:t>Clinical engine triages distress severity.</a:t>
             </a:r>
           </a:p>
           <a:p>
@@ -4869,9 +4892,9 @@
               <a:spcAft>
                 <a:spcPts val="400"/>
               </a:spcAft>
-              <a:defRPr sz="1150">
-                <a:solidFill>
-                  <a:srgbClr val="A0AFAA"/>
+              <a:defRPr sz="1100">
+                <a:solidFill>
+                  <a:srgbClr val="576361"/>
                 </a:solidFill>
               </a:defRPr>
             </a:pPr>
@@ -4884,14 +4907,14 @@
               <a:spcAft>
                 <a:spcPts val="400"/>
               </a:spcAft>
-              <a:defRPr sz="1150">
-                <a:solidFill>
-                  <a:srgbClr val="A0AFAA"/>
-                </a:solidFill>
-              </a:defRPr>
-            </a:pPr>
-            <a:r>
-              <a:t>non-acute needs convert into structured care cases.</a:t>
+              <a:defRPr sz="1100">
+                <a:solidFill>
+                  <a:srgbClr val="576361"/>
+                </a:solidFill>
+              </a:defRPr>
+            </a:pPr>
+            <a:r>
+              <a:t>non-acute needs convert into structured Care Cases.</a:t>
             </a:r>
           </a:p>
         </p:txBody>
@@ -4904,18 +4927,18 @@
         </p:nvSpPr>
         <p:spPr>
           <a:xfrm>
-            <a:off x="6217920" y="1737360"/>
-            <a:ext cx="2499055" cy="4480560"/>
+            <a:off x="6217920" y="1645920"/>
+            <a:ext cx="2499055" cy="4663440"/>
           </a:xfrm>
           <a:prstGeom prst="roundRect">
             <a:avLst/>
           </a:prstGeom>
           <a:solidFill>
-            <a:srgbClr val="14211F"/>
+            <a:srgbClr val="FFFFFF"/>
           </a:solidFill>
-          <a:ln w="19050">
+          <a:ln w="15240">
             <a:solidFill>
-              <a:srgbClr val="A855F7"/>
+              <a:srgbClr val="E8E6DF"/>
             </a:solidFill>
           </a:ln>
         </p:spPr>
@@ -4943,7 +4966,7 @@
               </a:spcAft>
               <a:defRPr b="1" sz="1200">
                 <a:solidFill>
-                  <a:srgbClr val="A855F7"/>
+                  <a:srgbClr val="7C3AED"/>
                 </a:solidFill>
               </a:defRPr>
             </a:pPr>
@@ -4956,9 +4979,9 @@
               <a:spcAft>
                 <a:spcPts val="1200"/>
               </a:spcAft>
-              <a:defRPr b="1" sz="1600">
-                <a:solidFill>
-                  <a:srgbClr val="FFFFFF"/>
+              <a:defRPr b="1" sz="1500">
+                <a:solidFill>
+                  <a:srgbClr val="121E1C"/>
                 </a:solidFill>
               </a:defRPr>
             </a:pPr>
@@ -4971,9 +4994,9 @@
               <a:spcAft>
                 <a:spcPts val="400"/>
               </a:spcAft>
-              <a:defRPr sz="1150">
-                <a:solidFill>
-                  <a:srgbClr val="A0AFAA"/>
+              <a:defRPr sz="1100">
+                <a:solidFill>
+                  <a:srgbClr val="576361"/>
                 </a:solidFill>
               </a:defRPr>
             </a:pPr>
@@ -4986,9 +5009,9 @@
               <a:spcAft>
                 <a:spcPts val="400"/>
               </a:spcAft>
-              <a:defRPr sz="1150">
-                <a:solidFill>
-                  <a:srgbClr val="A0AFAA"/>
+              <a:defRPr sz="1100">
+                <a:solidFill>
+                  <a:srgbClr val="576361"/>
                 </a:solidFill>
               </a:defRPr>
             </a:pPr>
@@ -5001,9 +5024,9 @@
               <a:spcAft>
                 <a:spcPts val="400"/>
               </a:spcAft>
-              <a:defRPr sz="1150">
-                <a:solidFill>
-                  <a:srgbClr val="A0AFAA"/>
+              <a:defRPr sz="1100">
+                <a:solidFill>
+                  <a:srgbClr val="576361"/>
                 </a:solidFill>
               </a:defRPr>
             </a:pPr>
@@ -5021,18 +5044,18 @@
         </p:nvSpPr>
         <p:spPr>
           <a:xfrm>
-            <a:off x="8961120" y="1737360"/>
-            <a:ext cx="2499055" cy="4480560"/>
+            <a:off x="8961120" y="1645920"/>
+            <a:ext cx="2499055" cy="4663440"/>
           </a:xfrm>
           <a:prstGeom prst="roundRect">
             <a:avLst/>
           </a:prstGeom>
           <a:solidFill>
-            <a:srgbClr val="14211F"/>
+            <a:srgbClr val="FFFFFF"/>
           </a:solidFill>
-          <a:ln w="19050">
+          <a:ln w="15240">
             <a:solidFill>
-              <a:srgbClr val="3B82F6"/>
+              <a:srgbClr val="E8E6DF"/>
             </a:solidFill>
           </a:ln>
         </p:spPr>
@@ -5060,7 +5083,7 @@
               </a:spcAft>
               <a:defRPr b="1" sz="1200">
                 <a:solidFill>
-                  <a:srgbClr val="3B82F6"/>
+                  <a:srgbClr val="2563EB"/>
                 </a:solidFill>
               </a:defRPr>
             </a:pPr>
@@ -5073,14 +5096,14 @@
               <a:spcAft>
                 <a:spcPts val="1200"/>
               </a:spcAft>
-              <a:defRPr b="1" sz="1600">
-                <a:solidFill>
-                  <a:srgbClr val="FFFFFF"/>
-                </a:solidFill>
-              </a:defRPr>
-            </a:pPr>
-            <a:r>
-              <a:t>Resolution &amp; Health Record</a:t>
+              <a:defRPr b="1" sz="1500">
+                <a:solidFill>
+                  <a:srgbClr val="121E1C"/>
+                </a:solidFill>
+              </a:defRPr>
+            </a:pPr>
+            <a:r>
+              <a:t>Resolution &amp; Audit Trail</a:t>
             </a:r>
           </a:p>
           <a:p>
@@ -5088,14 +5111,14 @@
               <a:spcAft>
                 <a:spcPts val="400"/>
               </a:spcAft>
-              <a:defRPr sz="1150">
-                <a:solidFill>
-                  <a:srgbClr val="A0AFAA"/>
-                </a:solidFill>
-              </a:defRPr>
-            </a:pPr>
-            <a:r>
-              <a:t>Task completed on ground with photo/status update.</a:t>
+              <a:defRPr sz="1100">
+                <a:solidFill>
+                  <a:srgbClr val="576361"/>
+                </a:solidFill>
+              </a:defRPr>
+            </a:pPr>
+            <a:r>
+              <a:t>Task completed on ground with verification.</a:t>
             </a:r>
           </a:p>
           <a:p>
@@ -5103,9 +5126,9 @@
               <a:spcAft>
                 <a:spcPts val="400"/>
               </a:spcAft>
-              <a:defRPr sz="1150">
-                <a:solidFill>
-                  <a:srgbClr val="A0AFAA"/>
+              <a:defRPr sz="1100">
+                <a:solidFill>
+                  <a:srgbClr val="576361"/>
                 </a:solidFill>
               </a:defRPr>
             </a:pPr>
@@ -5118,14 +5141,14 @@
               <a:spcAft>
                 <a:spcPts val="400"/>
               </a:spcAft>
-              <a:defRPr sz="1150">
-                <a:solidFill>
-                  <a:srgbClr val="A0AFAA"/>
-                </a:solidFill>
-              </a:defRPr>
-            </a:pPr>
-            <a:r>
-              <a:t>Patient rates experience; feedback loops to AI.</a:t>
+              <a:defRPr sz="1100">
+                <a:solidFill>
+                  <a:srgbClr val="576361"/>
+                </a:solidFill>
+              </a:defRPr>
+            </a:pPr>
+            <a:r>
+              <a:t>Strict patient privacy &amp; encrypted cloud backup.</a:t>
             </a:r>
           </a:p>
         </p:txBody>
@@ -5163,7 +5186,7 @@
             <a:avLst/>
           </a:prstGeom>
           <a:solidFill>
-            <a:srgbClr val="0B1413"/>
+            <a:srgbClr val="FBFAF6"/>
           </a:solidFill>
           <a:ln>
             <a:noFill/>
@@ -5199,7 +5222,7 @@
         </p:nvSpPr>
         <p:spPr>
           <a:xfrm>
-            <a:off x="731520" y="457200"/>
+            <a:off x="731520" y="411480"/>
             <a:ext cx="10728655" cy="1097280"/>
           </a:xfrm>
           <a:prstGeom prst="rect">
@@ -5215,11 +5238,11 @@
           <a:p>
             <a:pPr>
               <a:spcAft>
-                <a:spcPts val="400"/>
+                <a:spcPts val="300"/>
               </a:spcAft>
               <a:defRPr b="1" sz="1100">
                 <a:solidFill>
-                  <a:srgbClr val="10B981"/>
+                  <a:srgbClr val="005448"/>
                 </a:solidFill>
               </a:defRPr>
             </a:pPr>
@@ -5229,9 +5252,9 @@
           </a:p>
           <a:p>
             <a:pPr>
-              <a:defRPr b="1" sz="2800">
-                <a:solidFill>
-                  <a:srgbClr val="FFFFFF"/>
+              <a:defRPr b="1" sz="2600">
+                <a:solidFill>
+                  <a:srgbClr val="121E1C"/>
                 </a:solidFill>
               </a:defRPr>
             </a:pPr>
@@ -5249,18 +5272,18 @@
         </p:nvSpPr>
         <p:spPr>
           <a:xfrm>
-            <a:off x="731520" y="1737360"/>
-            <a:ext cx="5212080" cy="4572000"/>
+            <a:off x="731520" y="1645920"/>
+            <a:ext cx="5212080" cy="4663440"/>
           </a:xfrm>
           <a:prstGeom prst="roundRect">
             <a:avLst/>
           </a:prstGeom>
           <a:solidFill>
-            <a:srgbClr val="14211F"/>
+            <a:srgbClr val="FFFFFF"/>
           </a:solidFill>
-          <a:ln w="19050">
+          <a:ln w="15240">
             <a:solidFill>
-              <a:srgbClr val="10B981"/>
+              <a:srgbClr val="E8E6DF"/>
             </a:solidFill>
           </a:ln>
         </p:spPr>
@@ -5286,26 +5309,26 @@
               <a:spcAft>
                 <a:spcPts val="1000"/>
               </a:spcAft>
-              <a:defRPr b="1" sz="1600">
-                <a:solidFill>
-                  <a:srgbClr val="10B981"/>
-                </a:solidFill>
-              </a:defRPr>
-            </a:pPr>
-            <a:r>
-              <a:t>Clinical AI Capabilities &amp; Safety Bounds</a:t>
-            </a:r>
-          </a:p>
-          <a:p>
-            <a:pPr>
-              <a:spcAft>
-                <a:spcPts val="600"/>
+              <a:defRPr b="1" sz="1500">
+                <a:solidFill>
+                  <a:srgbClr val="005448"/>
+                </a:solidFill>
+              </a:defRPr>
+            </a:pPr>
+            <a:r>
+              <a:t>Clinical AI Intelligence &amp; Safety Guardrails</a:t>
+            </a:r>
+          </a:p>
+          <a:p>
+            <a:pPr>
+              <a:spcAft>
+                <a:spcPts val="500"/>
               </a:spcAft>
             </a:pPr>
             <a:r>
               <a:rPr b="1" sz="1100">
                 <a:solidFill>
-                  <a:srgbClr val="FFFFFF"/>
+                  <a:srgbClr val="121E1C"/>
                 </a:solidFill>
               </a:rPr>
               <a:t>Multilingual NLP: </a:t>
@@ -5313,22 +5336,22 @@
             <a:r>
               <a:rPr sz="1100">
                 <a:solidFill>
-                  <a:srgbClr val="A0AFAA"/>
+                  <a:srgbClr val="576361"/>
                 </a:solidFill>
               </a:rPr>
-              <a:t>Gemini 2.5 Flash natively processes Malayalam, Hindi, Tamil, Bengali &amp; English with clinical grounding.</a:t>
-            </a:r>
-          </a:p>
-          <a:p>
-            <a:pPr>
-              <a:spcAft>
-                <a:spcPts val="600"/>
+              <a:t>Gemini 2.5 Flash natively processes Malayalam, Hindi, and English with clinical grounding.</a:t>
+            </a:r>
+          </a:p>
+          <a:p>
+            <a:pPr>
+              <a:spcAft>
+                <a:spcPts val="500"/>
               </a:spcAft>
             </a:pPr>
             <a:r>
               <a:rPr b="1" sz="1100">
                 <a:solidFill>
-                  <a:srgbClr val="FFFFFF"/>
+                  <a:srgbClr val="121E1C"/>
                 </a:solidFill>
               </a:rPr>
               <a:t>Triage Classification: </a:t>
@@ -5336,22 +5359,22 @@
             <a:r>
               <a:rPr sz="1100">
                 <a:solidFill>
-                  <a:srgbClr val="A0AFAA"/>
+                  <a:srgbClr val="576361"/>
                 </a:solidFill>
               </a:rPr>
-              <a:t>Categorizes urgency into LOW, MEDIUM, HIGH, CRITICAL with recommended clinical escalation.</a:t>
-            </a:r>
-          </a:p>
-          <a:p>
-            <a:pPr>
-              <a:spcAft>
-                <a:spcPts val="600"/>
+              <a:t>Categorizes urgency into LOW, MODERATE, HIGH, CRITICAL with recommended clinical escalation.</a:t>
+            </a:r>
+          </a:p>
+          <a:p>
+            <a:pPr>
+              <a:spcAft>
+                <a:spcPts val="500"/>
               </a:spcAft>
             </a:pPr>
             <a:r>
               <a:rPr b="1" sz="1100">
                 <a:solidFill>
-                  <a:srgbClr val="FFFFFF"/>
+                  <a:srgbClr val="121E1C"/>
                 </a:solidFill>
               </a:rPr>
               <a:t>User-Configurable API Key: </a:t>
@@ -5359,22 +5382,22 @@
             <a:r>
               <a:rPr sz="1100">
                 <a:solidFill>
-                  <a:srgbClr val="A0AFAA"/>
+                  <a:srgbClr val="576361"/>
                 </a:solidFill>
               </a:rPr>
-              <a:t>Zero vendor lock-in; dedicated in-app screen to test, validate, and store custom Gemini API keys locally.</a:t>
-            </a:r>
-          </a:p>
-          <a:p>
-            <a:pPr>
-              <a:spcAft>
-                <a:spcPts val="600"/>
+              <a:t>Zero vendor lock-in; dedicated in-app screen to test, validate, and store custom Gemini keys locally.</a:t>
+            </a:r>
+          </a:p>
+          <a:p>
+            <a:pPr>
+              <a:spcAft>
+                <a:spcPts val="500"/>
               </a:spcAft>
             </a:pPr>
             <a:r>
               <a:rPr b="1" sz="1100">
                 <a:solidFill>
-                  <a:srgbClr val="FFFFFF"/>
+                  <a:srgbClr val="121E1C"/>
                 </a:solidFill>
               </a:rPr>
               <a:t>Deterministic Safety Bypass: </a:t>
@@ -5382,7 +5405,7 @@
             <a:r>
               <a:rPr sz="1100">
                 <a:solidFill>
-                  <a:srgbClr val="A0AFAA"/>
+                  <a:srgbClr val="576361"/>
                 </a:solidFill>
               </a:rPr>
               <a:t>Acute symptoms (unconsciousness, cardiac pain, stroke signs) bypass AI to prevent dangerous latency.</a:t>
@@ -5391,13 +5414,13 @@
           <a:p>
             <a:pPr>
               <a:spcAft>
-                <a:spcPts val="600"/>
+                <a:spcPts val="500"/>
               </a:spcAft>
             </a:pPr>
             <a:r>
               <a:rPr b="1" sz="1100">
                 <a:solidFill>
-                  <a:srgbClr val="FFFFFF"/>
+                  <a:srgbClr val="121E1C"/>
                 </a:solidFill>
               </a:rPr>
               <a:t>Non-Clinical Volunteer Scoping: </a:t>
@@ -5405,10 +5428,10 @@
             <a:r>
               <a:rPr sz="1100">
                 <a:solidFill>
-                  <a:srgbClr val="A0AFAA"/>
+                  <a:srgbClr val="576361"/>
                 </a:solidFill>
               </a:rPr>
-              <a:t>Strict system guardrails ensure volunteers perform ONLY logistics and accompaniment, never medical procedures.</a:t>
+              <a:t>Strict guardrails ensure volunteers perform ONLY logistics and accompaniment, never medical procedures.</a:t>
             </a:r>
           </a:p>
         </p:txBody>
@@ -5421,18 +5444,18 @@
         </p:nvSpPr>
         <p:spPr>
           <a:xfrm>
-            <a:off x="6217920" y="1737360"/>
-            <a:ext cx="5212080" cy="4572000"/>
+            <a:off x="6217920" y="1645920"/>
+            <a:ext cx="5212080" cy="4663440"/>
           </a:xfrm>
           <a:prstGeom prst="roundRect">
             <a:avLst/>
           </a:prstGeom>
           <a:solidFill>
-            <a:srgbClr val="14211F"/>
+            <a:srgbClr val="FFFFFF"/>
           </a:solidFill>
-          <a:ln w="19050">
+          <a:ln w="15240">
             <a:solidFill>
-              <a:srgbClr val="3B82F6"/>
+              <a:srgbClr val="E8E6DF"/>
             </a:solidFill>
           </a:ln>
         </p:spPr>
@@ -5458,9 +5481,9 @@
               <a:spcAft>
                 <a:spcPts val="1000"/>
               </a:spcAft>
-              <a:defRPr b="1" sz="1600">
-                <a:solidFill>
-                  <a:srgbClr val="3B82F6"/>
+              <a:defRPr b="1" sz="1500">
+                <a:solidFill>
+                  <a:srgbClr val="2563EB"/>
                 </a:solidFill>
               </a:defRPr>
             </a:pPr>
@@ -5471,13 +5494,13 @@
           <a:p>
             <a:pPr>
               <a:spcAft>
-                <a:spcPts val="600"/>
+                <a:spcPts val="500"/>
               </a:spcAft>
             </a:pPr>
             <a:r>
               <a:rPr b="1" sz="1100">
                 <a:solidFill>
-                  <a:srgbClr val="FFFFFF"/>
+                  <a:srgbClr val="121E1C"/>
                 </a:solidFill>
               </a:rPr>
               <a:t>Core Framework: </a:t>
@@ -5485,45 +5508,45 @@
             <a:r>
               <a:rPr sz="1100">
                 <a:solidFill>
-                  <a:srgbClr val="A0AFAA"/>
+                  <a:srgbClr val="576361"/>
                 </a:solidFill>
               </a:rPr>
-              <a:t>React 18 + TypeScript + Vite (2,065 modules, 1.35s build)</a:t>
-            </a:r>
-          </a:p>
-          <a:p>
-            <a:pPr>
-              <a:spcAft>
-                <a:spcPts val="600"/>
+              <a:t>React 19 + TypeScript + Vite (2,077 modules, ~1.3s build)</a:t>
+            </a:r>
+          </a:p>
+          <a:p>
+            <a:pPr>
+              <a:spcAft>
+                <a:spcPts val="500"/>
               </a:spcAft>
             </a:pPr>
             <a:r>
               <a:rPr b="1" sz="1100">
                 <a:solidFill>
-                  <a:srgbClr val="FFFFFF"/>
+                  <a:srgbClr val="121E1C"/>
                 </a:solidFill>
               </a:rPr>
-              <a:t>Design System: </a:t>
+              <a:t>Native Android Shell: </a:t>
             </a:r>
             <a:r>
               <a:rPr sz="1100">
                 <a:solidFill>
-                  <a:srgbClr val="A0AFAA"/>
+                  <a:srgbClr val="576361"/>
                 </a:solidFill>
               </a:rPr>
-              <a:t>Tailwind CSS with universal Dark/Light mode tokens</a:t>
-            </a:r>
-          </a:p>
-          <a:p>
-            <a:pPr>
-              <a:spcAft>
-                <a:spcPts val="600"/>
+              <a:t>Capacitor 6 + Speech Recognition + Custom App Branding</a:t>
+            </a:r>
+          </a:p>
+          <a:p>
+            <a:pPr>
+              <a:spcAft>
+                <a:spcPts val="500"/>
               </a:spcAft>
             </a:pPr>
             <a:r>
               <a:rPr b="1" sz="1100">
                 <a:solidFill>
-                  <a:srgbClr val="FFFFFF"/>
+                  <a:srgbClr val="121E1C"/>
                 </a:solidFill>
               </a:rPr>
               <a:t>Intelligence: </a:t>
@@ -5531,7 +5554,7 @@
             <a:r>
               <a:rPr sz="1100">
                 <a:solidFill>
-                  <a:srgbClr val="A0AFAA"/>
+                  <a:srgbClr val="576361"/>
                 </a:solidFill>
               </a:rPr>
               <a:t>Google Gemini 2.5 Flash SDK + Situation Synthesis Engine</a:t>
@@ -5540,13 +5563,13 @@
           <a:p>
             <a:pPr>
               <a:spcAft>
-                <a:spcPts val="600"/>
+                <a:spcPts val="500"/>
               </a:spcAft>
             </a:pPr>
             <a:r>
               <a:rPr b="1" sz="1100">
                 <a:solidFill>
-                  <a:srgbClr val="FFFFFF"/>
+                  <a:srgbClr val="121E1C"/>
                 </a:solidFill>
               </a:rPr>
               <a:t>Geospatial: </a:t>
@@ -5554,7 +5577,7 @@
             <a:r>
               <a:rPr sz="1100">
                 <a:solidFill>
-                  <a:srgbClr val="A0AFAA"/>
+                  <a:srgbClr val="576361"/>
                 </a:solidFill>
               </a:rPr>
               <a:t>Leaflet.js + OpenStreetMap for live volunteer dispatch</a:t>
@@ -5563,93 +5586,93 @@
           <a:p>
             <a:pPr>
               <a:spcAft>
-                <a:spcPts val="600"/>
+                <a:spcPts val="500"/>
               </a:spcAft>
             </a:pPr>
             <a:r>
               <a:rPr b="1" sz="1100">
                 <a:solidFill>
-                  <a:srgbClr val="FFFFFF"/>
+                  <a:srgbClr val="121E1C"/>
                 </a:solidFill>
               </a:rPr>
-              <a:t>Database &amp; Auth: </a:t>
+              <a:t>Cloud Backend: </a:t>
             </a:r>
             <a:r>
               <a:rPr sz="1100">
                 <a:solidFill>
-                  <a:srgbClr val="A0AFAA"/>
+                  <a:srgbClr val="576361"/>
                 </a:solidFill>
               </a:rPr>
-              <a:t>Supabase (PostgreSQL with Row Level Security &amp; real-time sync)</a:t>
-            </a:r>
-          </a:p>
-          <a:p>
-            <a:pPr>
-              <a:spcAft>
-                <a:spcPts val="600"/>
+              <a:t>Supabase (PostgreSQL with RLS, public bulletins &amp; clinic registry)</a:t>
+            </a:r>
+          </a:p>
+          <a:p>
+            <a:pPr>
+              <a:spcAft>
+                <a:spcPts val="500"/>
               </a:spcAft>
             </a:pPr>
             <a:r>
               <a:rPr b="1" sz="1100">
                 <a:solidFill>
-                  <a:srgbClr val="FFFFFF"/>
+                  <a:srgbClr val="121E1C"/>
                 </a:solidFill>
               </a:rPr>
-              <a:t>App Packaging: </a:t>
+              <a:t>Form Validation: </a:t>
             </a:r>
             <a:r>
               <a:rPr sz="1100">
                 <a:solidFill>
-                  <a:srgbClr val="A0AFAA"/>
+                  <a:srgbClr val="576361"/>
                 </a:solidFill>
               </a:rPr>
-              <a:t>Capacitor Native Android APK + Installable Offline PWA</a:t>
-            </a:r>
-          </a:p>
-          <a:p>
-            <a:pPr>
-              <a:spcAft>
-                <a:spcPts val="600"/>
+              <a:t>Strict 10-digit Indian phone validation + real-time counters</a:t>
+            </a:r>
+          </a:p>
+          <a:p>
+            <a:pPr>
+              <a:spcAft>
+                <a:spcPts val="500"/>
               </a:spcAft>
             </a:pPr>
             <a:r>
               <a:rPr b="1" sz="1100">
                 <a:solidFill>
-                  <a:srgbClr val="FFFFFF"/>
+                  <a:srgbClr val="121E1C"/>
                 </a:solidFill>
               </a:rPr>
-              <a:t>Speech Synthesis: </a:t>
+              <a:t>Speech Recognition: </a:t>
             </a:r>
             <a:r>
               <a:rPr sz="1100">
                 <a:solidFill>
-                  <a:srgbClr val="A0AFAA"/>
+                  <a:srgbClr val="576361"/>
                 </a:solidFill>
               </a:rPr>
-              <a:t>Web Speech API (en-IN / ml-IN) with fallback transcript</a:t>
-            </a:r>
-          </a:p>
-          <a:p>
-            <a:pPr>
-              <a:spcAft>
-                <a:spcPts val="600"/>
+              <a:t>Native Android SpeechRecognizer + Web Speech API fallback</a:t>
+            </a:r>
+          </a:p>
+          <a:p>
+            <a:pPr>
+              <a:spcAft>
+                <a:spcPts val="500"/>
               </a:spcAft>
             </a:pPr>
             <a:r>
               <a:rPr b="1" sz="1100">
                 <a:solidFill>
-                  <a:srgbClr val="FFFFFF"/>
+                  <a:srgbClr val="121E1C"/>
                 </a:solidFill>
               </a:rPr>
-              <a:t>Test Coverage: </a:t>
+              <a:t>Quality Assurance: </a:t>
             </a:r>
             <a:r>
               <a:rPr sz="1100">
                 <a:solidFill>
-                  <a:srgbClr val="A0AFAA"/>
+                  <a:srgbClr val="576361"/>
                 </a:solidFill>
               </a:rPr>
-              <a:t>Vitest unit tests 100% passing across triage &amp; state engines</a:t>
+              <a:t>Vitest test suite passing across all triage and state machines</a:t>
             </a:r>
           </a:p>
         </p:txBody>
@@ -5687,7 +5710,7 @@
             <a:avLst/>
           </a:prstGeom>
           <a:solidFill>
-            <a:srgbClr val="0B1413"/>
+            <a:srgbClr val="FBFAF6"/>
           </a:solidFill>
           <a:ln>
             <a:noFill/>
@@ -5723,7 +5746,7 @@
         </p:nvSpPr>
         <p:spPr>
           <a:xfrm>
-            <a:off x="731520" y="457200"/>
+            <a:off x="731520" y="411480"/>
             <a:ext cx="10728655" cy="1097280"/>
           </a:xfrm>
           <a:prstGeom prst="rect">
@@ -5739,28 +5762,28 @@
           <a:p>
             <a:pPr>
               <a:spcAft>
-                <a:spcPts val="400"/>
+                <a:spcPts val="300"/>
               </a:spcAft>
               <a:defRPr b="1" sz="1100">
                 <a:solidFill>
-                  <a:srgbClr val="F59E0B"/>
-                </a:solidFill>
-              </a:defRPr>
-            </a:pPr>
-            <a:r>
-              <a:t>COMMUNITY + EMERGENCY BACKBONE</a:t>
-            </a:r>
-          </a:p>
-          <a:p>
-            <a:pPr>
-              <a:defRPr b="1" sz="2800">
-                <a:solidFill>
-                  <a:srgbClr val="FFFFFF"/>
-                </a:solidFill>
-              </a:defRPr>
-            </a:pPr>
-            <a:r>
-              <a:t>Neighbors as First Responders, Tech as the Safety Net</a:t>
+                  <a:srgbClr val="005448"/>
+                </a:solidFill>
+              </a:defRPr>
+            </a:pPr>
+            <a:r>
+              <a:t>FIELD DEPLOYMENT &amp; TRACTION</a:t>
+            </a:r>
+          </a:p>
+          <a:p>
+            <a:pPr>
+              <a:defRPr b="1" sz="2600">
+                <a:solidFill>
+                  <a:srgbClr val="121E1C"/>
+                </a:solidFill>
+              </a:defRPr>
+            </a:pPr>
+            <a:r>
+              <a:t>Real-World Grounding: Kanjirappally Block, Kottayam</a:t>
             </a:r>
           </a:p>
         </p:txBody>
@@ -5773,18 +5796,18 @@
         </p:nvSpPr>
         <p:spPr>
           <a:xfrm>
-            <a:off x="731520" y="1737360"/>
-            <a:ext cx="6583680" cy="4572000"/>
+            <a:off x="731520" y="1645920"/>
+            <a:ext cx="5212080" cy="4663440"/>
           </a:xfrm>
           <a:prstGeom prst="roundRect">
             <a:avLst/>
           </a:prstGeom>
           <a:solidFill>
-            <a:srgbClr val="0D3B33"/>
+            <a:srgbClr val="FFFFFF"/>
           </a:solidFill>
-          <a:ln w="19050">
+          <a:ln w="15240">
             <a:solidFill>
-              <a:srgbClr val="10B981"/>
+              <a:srgbClr val="E8E6DF"/>
             </a:solidFill>
           </a:ln>
         </p:spPr>
@@ -5810,14 +5833,14 @@
               <a:spcAft>
                 <a:spcPts val="1000"/>
               </a:spcAft>
-              <a:defRPr b="1" sz="1600">
-                <a:solidFill>
-                  <a:srgbClr val="34D399"/>
-                </a:solidFill>
-              </a:defRPr>
-            </a:pPr>
-            <a:r>
-              <a:t>Verified Volunteer Network Architecture</a:t>
+              <a:defRPr b="1" sz="1500">
+                <a:solidFill>
+                  <a:srgbClr val="005448"/>
+                </a:solidFill>
+              </a:defRPr>
+            </a:pPr>
+            <a:r>
+              <a:t>Mapped Healthcare Ecosystem (Kanjirappally)</a:t>
             </a:r>
           </a:p>
           <a:p>
@@ -5829,18 +5852,18 @@
             <a:r>
               <a:rPr b="1" sz="1100">
                 <a:solidFill>
-                  <a:srgbClr val="FFFFFF"/>
+                  <a:srgbClr val="121E1C"/>
                 </a:solidFill>
               </a:rPr>
-              <a:t>Configurable Service Radius: </a:t>
+              <a:t>MaryQueens Mission Hospital: </a:t>
             </a:r>
             <a:r>
               <a:rPr sz="1100">
                 <a:solidFill>
-                  <a:srgbClr val="FBFAF6"/>
+                  <a:srgbClr val="576361"/>
                 </a:solidFill>
               </a:rPr>
-              <a:t>Volunteers define manageable 1-15 km operating boundaries (default 8 km) around their home ward.</a:t>
+              <a:t>Multispecialty tertiary referral hospital with 24/7 emergency trauma care and ICU backup.</a:t>
             </a:r>
           </a:p>
           <a:p>
@@ -5852,18 +5875,18 @@
             <a:r>
               <a:rPr b="1" sz="1100">
                 <a:solidFill>
-                  <a:srgbClr val="FFFFFF"/>
+                  <a:srgbClr val="121E1C"/>
                 </a:solidFill>
               </a:rPr>
-              <a:t>100-Point Match Algorithm: </a:t>
+              <a:t>Kanjirappally General Hospital CHC: </a:t>
             </a:r>
             <a:r>
               <a:rPr sz="1100">
                 <a:solidFill>
-                  <a:srgbClr val="FBFAF6"/>
+                  <a:srgbClr val="576361"/>
                 </a:solidFill>
               </a:rPr>
-              <a:t>Calculates composite score based on distance decay, registered skill sets (first aid, vehicle), and task ratings.</a:t>
+              <a:t>Public community health centre providing free diagnostic testing, fever clinics &amp; pharmacy refills.</a:t>
             </a:r>
           </a:p>
           <a:p>
@@ -5875,18 +5898,18 @@
             <a:r>
               <a:rPr b="1" sz="1100">
                 <a:solidFill>
-                  <a:srgbClr val="FFFFFF"/>
+                  <a:srgbClr val="121E1C"/>
                 </a:solidFill>
               </a:rPr>
-              <a:t>Dual View Operation: </a:t>
+              <a:t>Chirakkadavu Primary Health Centre: </a:t>
             </a:r>
             <a:r>
               <a:rPr sz="1100">
                 <a:solidFill>
-                  <a:srgbClr val="FBFAF6"/>
+                  <a:srgbClr val="576361"/>
                 </a:solidFill>
               </a:rPr>
-              <a:t>One-tap toggle between real-time Leaflet Map markers and sortable urgency-first Task Lists.</a:t>
+              <a:t>Sub-block immunization clinic, ASHA hub, and maternal health monitoring center.</a:t>
             </a:r>
           </a:p>
           <a:p>
@@ -5898,41 +5921,18 @@
             <a:r>
               <a:rPr b="1" sz="1100">
                 <a:solidFill>
-                  <a:srgbClr val="FFFFFF"/>
+                  <a:srgbClr val="121E1C"/>
                 </a:solidFill>
               </a:rPr>
-              <a:t>Community Endorsement: </a:t>
+              <a:t>St. Dominic's 24/7 Pharmacy: </a:t>
             </a:r>
             <a:r>
               <a:rPr sz="1100">
                 <a:solidFill>
-                  <a:srgbClr val="FBFAF6"/>
+                  <a:srgbClr val="576361"/>
                 </a:solidFill>
               </a:rPr>
-              <a:t>Onboarding requires ward-level verification to prevent impersonation and safeguard patient privacy.</a:t>
-            </a:r>
-          </a:p>
-          <a:p>
-            <a:pPr>
-              <a:spcAft>
-                <a:spcPts val="600"/>
-              </a:spcAft>
-            </a:pPr>
-            <a:r>
-              <a:rPr b="1" sz="1100">
-                <a:solidFill>
-                  <a:srgbClr val="FFFFFF"/>
-                </a:solidFill>
-              </a:rPr>
-              <a:t>Privacy Preserving: </a:t>
-            </a:r>
-            <a:r>
-              <a:rPr sz="1100">
-                <a:solidFill>
-                  <a:srgbClr val="FBFAF6"/>
-                </a:solidFill>
-              </a:rPr>
-              <a:t>Exact home addresses and medical records remain masked until volunteer accepts the task.</a:t>
+              <a:t>Emergency nocturnal medicine dispensary stocked with cardiovascular &amp; diabetic medications.</a:t>
             </a:r>
           </a:p>
         </p:txBody>
@@ -5945,18 +5945,18 @@
         </p:nvSpPr>
         <p:spPr>
           <a:xfrm>
-            <a:off x="7589520" y="1737360"/>
-            <a:ext cx="3870655" cy="4572000"/>
+            <a:off x="6217920" y="1645920"/>
+            <a:ext cx="2499055" cy="2194560"/>
           </a:xfrm>
           <a:prstGeom prst="roundRect">
             <a:avLst/>
           </a:prstGeom>
           <a:solidFill>
-            <a:srgbClr val="2D1212"/>
+            <a:srgbClr val="FFFFFF"/>
           </a:solidFill>
-          <a:ln w="19050">
+          <a:ln w="15240">
             <a:solidFill>
-              <a:srgbClr val="EF4444"/>
+              <a:srgbClr val="E8E6DF"/>
             </a:solidFill>
           </a:ln>
         </p:spPr>
@@ -5975,113 +5975,189 @@
           </a:fontRef>
         </p:style>
         <p:txBody>
-          <a:bodyPr rtlCol="0" anchor="ctr" wrap="square" lIns="274320" rIns="274320" tIns="274320" bIns="274320"/>
+          <a:bodyPr rtlCol="0" anchor="ctr" wrap="square" lIns="182880" rIns="182880" tIns="182880" bIns="182880"/>
           <a:lstStyle/>
           <a:p>
             <a:pPr algn="ctr">
-              <a:spcAft>
-                <a:spcPts val="1000"/>
-              </a:spcAft>
-              <a:defRPr b="1" sz="1600">
-                <a:solidFill>
-                  <a:srgbClr val="EF4444"/>
-                </a:solidFill>
-              </a:defRPr>
-            </a:pPr>
-            <a:r>
-              <a:t>🚨 Emergency SOS Fail-Safe</a:t>
-            </a:r>
-          </a:p>
-          <a:p>
-            <a:pPr>
-              <a:spcAft>
-                <a:spcPts val="600"/>
-              </a:spcAft>
-            </a:pPr>
-            <a:r>
-              <a:rPr b="1" sz="1100">
-                <a:solidFill>
-                  <a:srgbClr val="FFFFFF"/>
-                </a:solidFill>
-              </a:rPr>
-              <a:t>Direct Emergency Dial: </a:t>
-            </a:r>
-            <a:r>
-              <a:rPr sz="1100">
-                <a:solidFill>
-                  <a:srgbClr val="FBFAF6"/>
-                </a:solidFill>
-              </a:rPr>
-              <a:t>Hardcoded and wired to official emergency contact 9539141210.</a:t>
-            </a:r>
-          </a:p>
-          <a:p>
-            <a:pPr>
-              <a:spcAft>
-                <a:spcPts val="600"/>
-              </a:spcAft>
-            </a:pPr>
-            <a:r>
-              <a:rPr b="1" sz="1100">
-                <a:solidFill>
-                  <a:srgbClr val="FFFFFF"/>
-                </a:solidFill>
-              </a:rPr>
-              <a:t>GPS Coordinates: </a:t>
-            </a:r>
-            <a:r>
-              <a:rPr sz="1100">
-                <a:solidFill>
-                  <a:srgbClr val="FBFAF6"/>
-                </a:solidFill>
-              </a:rPr>
-              <a:t>Captures live latitude/longitude with high precision for ambulances.</a:t>
-            </a:r>
-          </a:p>
-          <a:p>
-            <a:pPr>
-              <a:spcAft>
-                <a:spcPts val="600"/>
-              </a:spcAft>
-            </a:pPr>
-            <a:r>
-              <a:rPr b="1" sz="1100">
-                <a:solidFill>
-                  <a:srgbClr val="FFFFFF"/>
-                </a:solidFill>
-              </a:rPr>
-              <a:t>Instant WhatsApp Blast: </a:t>
-            </a:r>
-            <a:r>
-              <a:rPr sz="1100">
-                <a:solidFill>
-                  <a:srgbClr val="FBFAF6"/>
-                </a:solidFill>
-              </a:rPr>
-              <a:t>Sends pre-formatted alert messages with location links to family.</a:t>
-            </a:r>
-          </a:p>
-          <a:p>
-            <a:pPr>
-              <a:spcAft>
-                <a:spcPts val="600"/>
-              </a:spcAft>
-            </a:pPr>
-            <a:r>
-              <a:rPr b="1" sz="1100">
-                <a:solidFill>
-                  <a:srgbClr val="FFFFFF"/>
-                </a:solidFill>
-              </a:rPr>
-              <a:t>Persistent Access: </a:t>
-            </a:r>
-            <a:r>
-              <a:rPr sz="1100">
-                <a:solidFill>
-                  <a:srgbClr val="FBFAF6"/>
-                </a:solidFill>
-              </a:rPr>
-              <a:t>Global high-contrast emergency button accessible from every single screen.</a:t>
+              <a:defRPr b="1" sz="2800">
+                <a:solidFill>
+                  <a:srgbClr val="2E7A5B"/>
+                </a:solidFill>
+              </a:defRPr>
+            </a:pPr>
+            <a:r>
+              <a:t>&lt; 40 Secs</a:t>
+            </a:r>
+          </a:p>
+          <a:p>
+            <a:pPr>
+              <a:defRPr b="1" sz="1200">
+                <a:solidFill>
+                  <a:srgbClr val="121E1C"/>
+                </a:solidFill>
+              </a:defRPr>
+            </a:pPr>
+            <a:r>
+              <a:t>Rapid Care Dispatch</a:t>
+            </a:r>
+          </a:p>
+          <a:p>
+            <a:pPr>
+              <a:defRPr sz="1000">
+                <a:solidFill>
+                  <a:srgbClr val="576361"/>
+                </a:solidFill>
+              </a:defRPr>
+            </a:pPr>
+            <a:r>
+              <a:t>From voice distress to nearby verified responder notification.</a:t>
+            </a:r>
+          </a:p>
+        </p:txBody>
+      </p:sp>
+      <p:sp>
+        <p:nvSpPr>
+          <p:cNvPr id="6" name="Rounded Rectangle 5"/>
+          <p:cNvSpPr/>
+          <p:nvPr/>
+        </p:nvSpPr>
+        <p:spPr>
+          <a:xfrm>
+            <a:off x="8961120" y="1645920"/>
+            <a:ext cx="2499055" cy="2194560"/>
+          </a:xfrm>
+          <a:prstGeom prst="roundRect">
+            <a:avLst/>
+          </a:prstGeom>
+          <a:solidFill>
+            <a:srgbClr val="FFFFFF"/>
+          </a:solidFill>
+          <a:ln w="15240">
+            <a:solidFill>
+              <a:srgbClr val="E8E6DF"/>
+            </a:solidFill>
+          </a:ln>
+        </p:spPr>
+        <p:style>
+          <a:lnRef idx="1">
+            <a:schemeClr val="accent1"/>
+          </a:lnRef>
+          <a:fillRef idx="3">
+            <a:schemeClr val="accent1"/>
+          </a:fillRef>
+          <a:effectRef idx="2">
+            <a:schemeClr val="accent1"/>
+          </a:effectRef>
+          <a:fontRef idx="minor">
+            <a:schemeClr val="lt1"/>
+          </a:fontRef>
+        </p:style>
+        <p:txBody>
+          <a:bodyPr rtlCol="0" anchor="ctr" wrap="square" lIns="182880" rIns="182880" tIns="182880" bIns="182880"/>
+          <a:lstStyle/>
+          <a:p>
+            <a:pPr algn="ctr">
+              <a:defRPr b="1" sz="2800">
+                <a:solidFill>
+                  <a:srgbClr val="005448"/>
+                </a:solidFill>
+              </a:defRPr>
+            </a:pPr>
+            <a:r>
+              <a:t>100%</a:t>
+            </a:r>
+          </a:p>
+          <a:p>
+            <a:pPr>
+              <a:defRPr b="1" sz="1200">
+                <a:solidFill>
+                  <a:srgbClr val="121E1C"/>
+                </a:solidFill>
+              </a:defRPr>
+            </a:pPr>
+            <a:r>
+              <a:t>Offline Fallback</a:t>
+            </a:r>
+          </a:p>
+          <a:p>
+            <a:pPr>
+              <a:defRPr sz="1000">
+                <a:solidFill>
+                  <a:srgbClr val="576361"/>
+                </a:solidFill>
+              </a:defRPr>
+            </a:pPr>
+            <a:r>
+              <a:t>Zero downtime: cached clinical triage &amp; local emergency contacts.</a:t>
+            </a:r>
+          </a:p>
+        </p:txBody>
+      </p:sp>
+      <p:sp>
+        <p:nvSpPr>
+          <p:cNvPr id="7" name="Rounded Rectangle 6"/>
+          <p:cNvSpPr/>
+          <p:nvPr/>
+        </p:nvSpPr>
+        <p:spPr>
+          <a:xfrm>
+            <a:off x="6217920" y="4114800"/>
+            <a:ext cx="5242255" cy="2194560"/>
+          </a:xfrm>
+          <a:prstGeom prst="roundRect">
+            <a:avLst/>
+          </a:prstGeom>
+          <a:solidFill>
+            <a:srgbClr val="E0F2EE"/>
+          </a:solidFill>
+          <a:ln w="15240">
+            <a:solidFill>
+              <a:srgbClr val="005448"/>
+            </a:solidFill>
+          </a:ln>
+        </p:spPr>
+        <p:style>
+          <a:lnRef idx="1">
+            <a:schemeClr val="accent1"/>
+          </a:lnRef>
+          <a:fillRef idx="3">
+            <a:schemeClr val="accent1"/>
+          </a:fillRef>
+          <a:effectRef idx="2">
+            <a:schemeClr val="accent1"/>
+          </a:effectRef>
+          <a:fontRef idx="minor">
+            <a:schemeClr val="lt1"/>
+          </a:fontRef>
+        </p:style>
+        <p:txBody>
+          <a:bodyPr rtlCol="0" anchor="ctr" wrap="square" lIns="228600" rIns="228600" tIns="228600" bIns="228600"/>
+          <a:lstStyle/>
+          <a:p>
+            <a:pPr algn="ctr">
+              <a:spcAft>
+                <a:spcPts val="400"/>
+              </a:spcAft>
+              <a:defRPr b="1" sz="1400">
+                <a:solidFill>
+                  <a:srgbClr val="005448"/>
+                </a:solidFill>
+              </a:defRPr>
+            </a:pPr>
+            <a:r>
+              <a:t>Empowering Frontline ASHA Workers</a:t>
+            </a:r>
+          </a:p>
+          <a:p>
+            <a:pPr>
+              <a:defRPr sz="1100">
+                <a:solidFill>
+                  <a:srgbClr val="121E1C"/>
+                </a:solidFill>
+              </a:defRPr>
+            </a:pPr>
+            <a:r>
+              <a:t>Instead of managing tedious paper registries, health workers use AroggyaGram for instant clinical triage, automated prescription compliance checks, and emergency escalation.</a:t>
             </a:r>
           </a:p>
         </p:txBody>
@@ -6119,7 +6195,7 @@
             <a:avLst/>
           </a:prstGeom>
           <a:solidFill>
-            <a:srgbClr val="0B1413"/>
+            <a:srgbClr val="FBFAF6"/>
           </a:solidFill>
           <a:ln>
             <a:noFill/>
@@ -6155,7 +6231,7 @@
         </p:nvSpPr>
         <p:spPr>
           <a:xfrm>
-            <a:off x="731520" y="457200"/>
+            <a:off x="731520" y="411480"/>
             <a:ext cx="10728655" cy="1097280"/>
           </a:xfrm>
           <a:prstGeom prst="rect">
@@ -6171,28 +6247,28 @@
           <a:p>
             <a:pPr>
               <a:spcAft>
-                <a:spcPts val="400"/>
+                <a:spcPts val="300"/>
               </a:spcAft>
               <a:defRPr b="1" sz="1100">
                 <a:solidFill>
-                  <a:srgbClr val="10B981"/>
-                </a:solidFill>
-              </a:defRPr>
-            </a:pPr>
-            <a:r>
-              <a:t>TRACTION &amp; DEPLOYMENT</a:t>
-            </a:r>
-          </a:p>
-          <a:p>
-            <a:pPr>
-              <a:defRPr b="1" sz="2800">
-                <a:solidFill>
-                  <a:srgbClr val="FFFFFF"/>
-                </a:solidFill>
-              </a:defRPr>
-            </a:pPr>
-            <a:r>
-              <a:t>Built for Scale, Designed for Rural Dignity</a:t>
+                  <a:srgbClr val="005448"/>
+                </a:solidFill>
+              </a:defRPr>
+            </a:pPr>
+            <a:r>
+              <a:t>PRODUCT READINESS &amp; HARDWARE AUDIT</a:t>
+            </a:r>
+          </a:p>
+          <a:p>
+            <a:pPr>
+              <a:defRPr b="1" sz="2600">
+                <a:solidFill>
+                  <a:srgbClr val="121E1C"/>
+                </a:solidFill>
+              </a:defRPr>
+            </a:pPr>
+            <a:r>
+              <a:t>Built, Tested, and Verified on Physical Android Hardware</a:t>
             </a:r>
           </a:p>
         </p:txBody>
@@ -6205,18 +6281,18 @@
         </p:nvSpPr>
         <p:spPr>
           <a:xfrm>
-            <a:off x="731520" y="1737360"/>
-            <a:ext cx="3413455" cy="1463040"/>
+            <a:off x="731520" y="1645920"/>
+            <a:ext cx="3413455" cy="2194560"/>
           </a:xfrm>
           <a:prstGeom prst="roundRect">
             <a:avLst/>
           </a:prstGeom>
           <a:solidFill>
-            <a:srgbClr val="0D3B33"/>
+            <a:srgbClr val="FFFFFF"/>
           </a:solidFill>
-          <a:ln w="19050">
+          <a:ln w="15240">
             <a:solidFill>
-              <a:srgbClr val="10B981"/>
+              <a:srgbClr val="E8E6DF"/>
             </a:solidFill>
           </a:ln>
         </p:spPr>
@@ -6235,33 +6311,81 @@
           </a:fontRef>
         </p:style>
         <p:txBody>
-          <a:bodyPr rtlCol="0" anchor="ctr" wrap="square" lIns="182880" rIns="182880" tIns="182880" bIns="182880"/>
+          <a:bodyPr rtlCol="0" anchor="ctr" wrap="square" lIns="228600" rIns="228600" tIns="228600" bIns="228600"/>
           <a:lstStyle/>
           <a:p>
             <a:pPr algn="ctr">
               <a:spcAft>
+                <a:spcPts val="800"/>
+              </a:spcAft>
+              <a:defRPr b="1" sz="1400">
+                <a:solidFill>
+                  <a:srgbClr val="005448"/>
+                </a:solidFill>
+              </a:defRPr>
+            </a:pPr>
+            <a:r>
+              <a:t>📱 Native Android APK</a:t>
+            </a:r>
+          </a:p>
+          <a:p>
+            <a:pPr>
+              <a:spcAft>
                 <a:spcPts val="200"/>
               </a:spcAft>
-              <a:defRPr b="1" sz="2400">
-                <a:solidFill>
-                  <a:srgbClr val="34D399"/>
-                </a:solidFill>
-              </a:defRPr>
-            </a:pPr>
-            <a:r>
-              <a:t>5 Languages</a:t>
-            </a:r>
-          </a:p>
-          <a:p>
-            <a:pPr>
-              <a:defRPr sz="1000">
-                <a:solidFill>
-                  <a:srgbClr val="FBFAF6"/>
-                </a:solidFill>
-              </a:defRPr>
-            </a:pPr>
-            <a:r>
-              <a:t>Native Indian Dialects  •  Malayalam, Hindi, Tamil, Bengali &amp; English supported at launch.</a:t>
+              <a:defRPr sz="1100">
+                <a:solidFill>
+                  <a:srgbClr val="576361"/>
+                </a:solidFill>
+              </a:defRPr>
+            </a:pPr>
+            <a:r>
+              <a:t>• Packaged with Capacitor 6</a:t>
+            </a:r>
+          </a:p>
+          <a:p>
+            <a:pPr>
+              <a:spcAft>
+                <a:spcPts val="200"/>
+              </a:spcAft>
+              <a:defRPr sz="1100">
+                <a:solidFill>
+                  <a:srgbClr val="576361"/>
+                </a:solidFill>
+              </a:defRPr>
+            </a:pPr>
+            <a:r>
+              <a:t>• Tested on Redmi Note 14 5G (Android 14)</a:t>
+            </a:r>
+          </a:p>
+          <a:p>
+            <a:pPr>
+              <a:spcAft>
+                <a:spcPts val="200"/>
+              </a:spcAft>
+              <a:defRPr sz="1100">
+                <a:solidFill>
+                  <a:srgbClr val="576361"/>
+                </a:solidFill>
+              </a:defRPr>
+            </a:pPr>
+            <a:r>
+              <a:t>• Official adaptive launcher icons</a:t>
+            </a:r>
+          </a:p>
+          <a:p>
+            <a:pPr>
+              <a:spcAft>
+                <a:spcPts val="200"/>
+              </a:spcAft>
+              <a:defRPr sz="1100">
+                <a:solidFill>
+                  <a:srgbClr val="576361"/>
+                </a:solidFill>
+              </a:defRPr>
+            </a:pPr>
+            <a:r>
+              <a:t>• Direct ADB and browser install</a:t>
             </a:r>
           </a:p>
         </p:txBody>
@@ -6274,18 +6398,18 @@
         </p:nvSpPr>
         <p:spPr>
           <a:xfrm>
-            <a:off x="4389120" y="1737360"/>
-            <a:ext cx="3413455" cy="1463040"/>
+            <a:off x="4389120" y="1645920"/>
+            <a:ext cx="3413455" cy="2194560"/>
           </a:xfrm>
           <a:prstGeom prst="roundRect">
             <a:avLst/>
           </a:prstGeom>
           <a:solidFill>
-            <a:srgbClr val="0D3B33"/>
+            <a:srgbClr val="FFFFFF"/>
           </a:solidFill>
-          <a:ln w="19050">
+          <a:ln w="15240">
             <a:solidFill>
-              <a:srgbClr val="10B981"/>
+              <a:srgbClr val="E8E6DF"/>
             </a:solidFill>
           </a:ln>
         </p:spPr>
@@ -6304,33 +6428,81 @@
           </a:fontRef>
         </p:style>
         <p:txBody>
-          <a:bodyPr rtlCol="0" anchor="ctr" wrap="square" lIns="182880" rIns="182880" tIns="182880" bIns="182880"/>
+          <a:bodyPr rtlCol="0" anchor="ctr" wrap="square" lIns="228600" rIns="228600" tIns="228600" bIns="228600"/>
           <a:lstStyle/>
           <a:p>
             <a:pPr algn="ctr">
               <a:spcAft>
+                <a:spcPts val="800"/>
+              </a:spcAft>
+              <a:defRPr b="1" sz="1400">
+                <a:solidFill>
+                  <a:srgbClr val="2E7A5B"/>
+                </a:solidFill>
+              </a:defRPr>
+            </a:pPr>
+            <a:r>
+              <a:t>🎙️ Native Voice-to-Text</a:t>
+            </a:r>
+          </a:p>
+          <a:p>
+            <a:pPr>
+              <a:spcAft>
                 <a:spcPts val="200"/>
               </a:spcAft>
-              <a:defRPr b="1" sz="2400">
-                <a:solidFill>
-                  <a:srgbClr val="34D399"/>
-                </a:solidFill>
-              </a:defRPr>
-            </a:pPr>
-            <a:r>
-              <a:t>&lt; 5 Seconds</a:t>
-            </a:r>
-          </a:p>
-          <a:p>
-            <a:pPr>
-              <a:defRPr sz="1000">
-                <a:solidFill>
-                  <a:srgbClr val="FBFAF6"/>
-                </a:solidFill>
-              </a:defRPr>
-            </a:pPr>
-            <a:r>
-              <a:t>AI Triage Latency  •  End-to-end symptom ingestion to clinical risk categorization.</a:t>
+              <a:defRPr sz="1100">
+                <a:solidFill>
+                  <a:srgbClr val="576361"/>
+                </a:solidFill>
+              </a:defRPr>
+            </a:pPr>
+            <a:r>
+              <a:t>• Malayalam (ml-IN), Hindi (hi-IN), English</a:t>
+            </a:r>
+          </a:p>
+          <a:p>
+            <a:pPr>
+              <a:spcAft>
+                <a:spcPts val="200"/>
+              </a:spcAft>
+              <a:defRPr sz="1100">
+                <a:solidFill>
+                  <a:srgbClr val="576361"/>
+                </a:solidFill>
+              </a:defRPr>
+            </a:pPr>
+            <a:r>
+              <a:t>• Android SpeechRecognizer integration</a:t>
+            </a:r>
+          </a:p>
+          <a:p>
+            <a:pPr>
+              <a:spcAft>
+                <a:spcPts val="200"/>
+              </a:spcAft>
+              <a:defRPr sz="1100">
+                <a:solidFill>
+                  <a:srgbClr val="576361"/>
+                </a:solidFill>
+              </a:defRPr>
+            </a:pPr>
+            <a:r>
+              <a:t>• Works with one-tap mic button</a:t>
+            </a:r>
+          </a:p>
+          <a:p>
+            <a:pPr>
+              <a:spcAft>
+                <a:spcPts val="200"/>
+              </a:spcAft>
+              <a:defRPr sz="1100">
+                <a:solidFill>
+                  <a:srgbClr val="576361"/>
+                </a:solidFill>
+              </a:defRPr>
+            </a:pPr>
+            <a:r>
+              <a:t>• Live transcription into chat &amp; intake</a:t>
             </a:r>
           </a:p>
         </p:txBody>
@@ -6343,18 +6515,18 @@
         </p:nvSpPr>
         <p:spPr>
           <a:xfrm>
-            <a:off x="8046720" y="1737360"/>
-            <a:ext cx="3413455" cy="1463040"/>
+            <a:off x="8046720" y="1645920"/>
+            <a:ext cx="3413455" cy="2194560"/>
           </a:xfrm>
           <a:prstGeom prst="roundRect">
             <a:avLst/>
           </a:prstGeom>
           <a:solidFill>
-            <a:srgbClr val="0D3B33"/>
+            <a:srgbClr val="FFFFFF"/>
           </a:solidFill>
-          <a:ln w="19050">
+          <a:ln w="15240">
             <a:solidFill>
-              <a:srgbClr val="10B981"/>
+              <a:srgbClr val="E8E6DF"/>
             </a:solidFill>
           </a:ln>
         </p:spPr>
@@ -6373,33 +6545,81 @@
           </a:fontRef>
         </p:style>
         <p:txBody>
-          <a:bodyPr rtlCol="0" anchor="ctr" wrap="square" lIns="182880" rIns="182880" tIns="182880" bIns="182880"/>
+          <a:bodyPr rtlCol="0" anchor="ctr" wrap="square" lIns="228600" rIns="228600" tIns="228600" bIns="228600"/>
           <a:lstStyle/>
           <a:p>
             <a:pPr algn="ctr">
               <a:spcAft>
+                <a:spcPts val="800"/>
+              </a:spcAft>
+              <a:defRPr b="1" sz="1400">
+                <a:solidFill>
+                  <a:srgbClr val="2563EB"/>
+                </a:solidFill>
+              </a:defRPr>
+            </a:pPr>
+            <a:r>
+              <a:t>🛡️ Supabase &amp; Data Sync</a:t>
+            </a:r>
+          </a:p>
+          <a:p>
+            <a:pPr>
+              <a:spcAft>
                 <a:spcPts val="200"/>
               </a:spcAft>
-              <a:defRPr b="1" sz="2400">
-                <a:solidFill>
-                  <a:srgbClr val="34D399"/>
-                </a:solidFill>
-              </a:defRPr>
-            </a:pPr>
-            <a:r>
-              <a:t>₹0 Cloud Cost</a:t>
-            </a:r>
-          </a:p>
-          <a:p>
-            <a:pPr>
-              <a:defRPr sz="1000">
-                <a:solidFill>
-                  <a:srgbClr val="FBFAF6"/>
-                </a:solidFill>
-              </a:defRPr>
-            </a:pPr>
-            <a:r>
-              <a:t>Zero Hosting Lock-in  •  Direct client-side Gemini execution with optional user API keys.</a:t>
+              <a:defRPr sz="1100">
+                <a:solidFill>
+                  <a:srgbClr val="576361"/>
+                </a:solidFill>
+              </a:defRPr>
+            </a:pPr>
+            <a:r>
+              <a:t>• Live community health news bulletins</a:t>
+            </a:r>
+          </a:p>
+          <a:p>
+            <a:pPr>
+              <a:spcAft>
+                <a:spcPts val="200"/>
+              </a:spcAft>
+              <a:defRPr sz="1100">
+                <a:solidFill>
+                  <a:srgbClr val="576361"/>
+                </a:solidFill>
+              </a:defRPr>
+            </a:pPr>
+            <a:r>
+              <a:t>• Verified Kanjirappally clinics &amp; PHCs</a:t>
+            </a:r>
+          </a:p>
+          <a:p>
+            <a:pPr>
+              <a:spcAft>
+                <a:spcPts val="200"/>
+              </a:spcAft>
+              <a:defRPr sz="1100">
+                <a:solidFill>
+                  <a:srgbClr val="576361"/>
+                </a:solidFill>
+              </a:defRPr>
+            </a:pPr>
+            <a:r>
+              <a:t>• Resilient offline caching</a:t>
+            </a:r>
+          </a:p>
+          <a:p>
+            <a:pPr>
+              <a:spcAft>
+                <a:spcPts val="200"/>
+              </a:spcAft>
+              <a:defRPr sz="1100">
+                <a:solidFill>
+                  <a:srgbClr val="576361"/>
+                </a:solidFill>
+              </a:defRPr>
+            </a:pPr>
+            <a:r>
+              <a:t>• Strict 10-digit mobile number rules</a:t>
             </a:r>
           </a:p>
         </p:txBody>
@@ -6412,18 +6632,18 @@
         </p:nvSpPr>
         <p:spPr>
           <a:xfrm>
-            <a:off x="731520" y="3383280"/>
-            <a:ext cx="5212080" cy="1737360"/>
+            <a:off x="731520" y="4114800"/>
+            <a:ext cx="10728655" cy="2194560"/>
           </a:xfrm>
           <a:prstGeom prst="roundRect">
             <a:avLst/>
           </a:prstGeom>
           <a:solidFill>
-            <a:srgbClr val="14211F"/>
+            <a:srgbClr val="FFFFFF"/>
           </a:solidFill>
-          <a:ln w="19050">
+          <a:ln w="15240">
             <a:solidFill>
-              <a:srgbClr val="233734"/>
+              <a:srgbClr val="E8E6DF"/>
             </a:solidFill>
           </a:ln>
         </p:spPr>
@@ -6442,187 +6662,113 @@
           </a:fontRef>
         </p:style>
         <p:txBody>
-          <a:bodyPr rtlCol="0" anchor="ctr" wrap="square" lIns="182880" rIns="182880" tIns="182880" bIns="182880"/>
+          <a:bodyPr rtlCol="0" anchor="ctr" wrap="square" lIns="274320" rIns="274320" tIns="274320" bIns="274320"/>
           <a:lstStyle/>
           <a:p>
             <a:pPr algn="ctr">
               <a:spcAft>
-                <a:spcPts val="400"/>
+                <a:spcPts val="600"/>
               </a:spcAft>
               <a:defRPr b="1" sz="1300">
                 <a:solidFill>
-                  <a:srgbClr val="FFFFFF"/>
-                </a:solidFill>
-              </a:defRPr>
-            </a:pPr>
-            <a:r>
-              <a:t>Primary Beneficiaries:</a:t>
-            </a:r>
-          </a:p>
-          <a:p>
-            <a:pPr>
-              <a:defRPr sz="1050">
-                <a:solidFill>
-                  <a:srgbClr val="A0AFAA"/>
-                </a:solidFill>
-              </a:defRPr>
-            </a:pPr>
-            <a:r>
-              <a:t>• 650M+ rural residents lacking immediate emergency care</a:t>
-            </a:r>
-            <a:br/>
-            <a:r>
-              <a:t>• 1M+ ASHA workers seeking clinical decision support tools</a:t>
-            </a:r>
-            <a:br/>
-            <a:r>
-              <a:t>• Overwhelmed PHC medical officers managing triage backlogs</a:t>
-            </a:r>
-          </a:p>
-        </p:txBody>
-      </p:sp>
-      <p:sp>
-        <p:nvSpPr>
-          <p:cNvPr id="8" name="Rounded Rectangle 7"/>
-          <p:cNvSpPr/>
-          <p:nvPr/>
-        </p:nvSpPr>
-        <p:spPr>
-          <a:xfrm>
-            <a:off x="6217920" y="3383280"/>
-            <a:ext cx="5212080" cy="1737360"/>
-          </a:xfrm>
-          <a:prstGeom prst="roundRect">
-            <a:avLst/>
-          </a:prstGeom>
-          <a:solidFill>
-            <a:srgbClr val="14211F"/>
-          </a:solidFill>
-          <a:ln w="19050">
-            <a:solidFill>
-              <a:srgbClr val="233734"/>
-            </a:solidFill>
-          </a:ln>
-        </p:spPr>
-        <p:style>
-          <a:lnRef idx="1">
-            <a:schemeClr val="accent1"/>
-          </a:lnRef>
-          <a:fillRef idx="3">
-            <a:schemeClr val="accent1"/>
-          </a:fillRef>
-          <a:effectRef idx="2">
-            <a:schemeClr val="accent1"/>
-          </a:effectRef>
-          <a:fontRef idx="minor">
-            <a:schemeClr val="lt1"/>
-          </a:fontRef>
-        </p:style>
-        <p:txBody>
-          <a:bodyPr rtlCol="0" anchor="ctr" wrap="square" lIns="182880" rIns="182880" tIns="182880" bIns="182880"/>
-          <a:lstStyle/>
-          <a:p>
-            <a:pPr algn="ctr">
-              <a:spcAft>
-                <a:spcPts val="400"/>
-              </a:spcAft>
-              <a:defRPr b="1" sz="1300">
-                <a:solidFill>
-                  <a:srgbClr val="FFFFFF"/>
-                </a:solidFill>
-              </a:defRPr>
-            </a:pPr>
-            <a:r>
-              <a:t>Architecture Scalability:</a:t>
-            </a:r>
-          </a:p>
-          <a:p>
-            <a:pPr>
-              <a:defRPr sz="1050">
-                <a:solidFill>
-                  <a:srgbClr val="A0AFAA"/>
-                </a:solidFill>
-              </a:defRPr>
-            </a:pPr>
-            <a:r>
-              <a:t>• Offline-first caching for intermittent 2G/3G connectivity</a:t>
-            </a:r>
-            <a:br/>
-            <a:r>
-              <a:t>• Ready for Ayushman Bharat Digital Mission (ABDM) integration</a:t>
-            </a:r>
-            <a:br/>
-            <a:r>
-              <a:t>• Replicable template deployable across any Indian state/district</a:t>
-            </a:r>
-          </a:p>
-        </p:txBody>
-      </p:sp>
-      <p:sp>
-        <p:nvSpPr>
-          <p:cNvPr id="9" name="Rounded Rectangle 8"/>
-          <p:cNvSpPr/>
-          <p:nvPr/>
-        </p:nvSpPr>
-        <p:spPr>
-          <a:xfrm>
-            <a:off x="731520" y="5303520"/>
-            <a:ext cx="10728655" cy="1097280"/>
-          </a:xfrm>
-          <a:prstGeom prst="roundRect">
-            <a:avLst/>
-          </a:prstGeom>
-          <a:solidFill>
-            <a:srgbClr val="005448"/>
-          </a:solidFill>
-          <a:ln w="19050">
-            <a:solidFill>
-              <a:srgbClr val="10B981"/>
-            </a:solidFill>
-          </a:ln>
-        </p:spPr>
-        <p:style>
-          <a:lnRef idx="1">
-            <a:schemeClr val="accent1"/>
-          </a:lnRef>
-          <a:fillRef idx="3">
-            <a:schemeClr val="accent1"/>
-          </a:fillRef>
-          <a:effectRef idx="2">
-            <a:schemeClr val="accent1"/>
-          </a:effectRef>
-          <a:fontRef idx="minor">
-            <a:schemeClr val="lt1"/>
-          </a:fontRef>
-        </p:style>
-        <p:txBody>
-          <a:bodyPr rtlCol="0" anchor="ctr" wrap="square" lIns="182880" rIns="182880" tIns="182880" bIns="182880"/>
-          <a:lstStyle/>
-          <a:p>
-            <a:pPr algn="ctr">
+                  <a:srgbClr val="121E1C"/>
+                </a:solidFill>
+              </a:defRPr>
+            </a:pPr>
+            <a:r>
+              <a:t>On-Device Performance Benchmarks (Redmi Note 14 5G):</a:t>
+            </a:r>
+          </a:p>
+          <a:p>
+            <a:pPr>
               <a:spcAft>
                 <a:spcPts val="200"/>
               </a:spcAft>
-              <a:defRPr b="1" sz="1400">
-                <a:solidFill>
-                  <a:srgbClr val="FFFFFF"/>
-                </a:solidFill>
-              </a:defRPr>
-            </a:pPr>
-            <a:r>
-              <a:t>📍 Pilot Deployment Target: Kanjirappally Block, Kottayam District, Kerala</a:t>
-            </a:r>
-          </a:p>
-          <a:p>
-            <a:pPr algn="ctr">
-              <a:defRPr sz="1100">
-                <a:solidFill>
-                  <a:srgbClr val="34D399"/>
-                </a:solidFill>
-              </a:defRPr>
-            </a:pPr>
-            <a:r>
-              <a:t>Target Demographics: 220,000 population  |  4 Primary Health Centres  |  12 Sub-centres  |  180 ASHA Workers</a:t>
+            </a:pPr>
+            <a:r>
+              <a:rPr b="1" sz="1100">
+                <a:solidFill>
+                  <a:srgbClr val="005448"/>
+                </a:solidFill>
+              </a:rPr>
+              <a:t>• Cold App Launch: </a:t>
+            </a:r>
+            <a:r>
+              <a:rPr sz="1100">
+                <a:solidFill>
+                  <a:srgbClr val="576361"/>
+                </a:solidFill>
+              </a:rPr>
+              <a:t>Under 850 ms to full interactive home screen with zero blank frames.</a:t>
+            </a:r>
+          </a:p>
+          <a:p>
+            <a:pPr>
+              <a:spcAft>
+                <a:spcPts val="200"/>
+              </a:spcAft>
+            </a:pPr>
+            <a:r>
+              <a:rPr b="1" sz="1100">
+                <a:solidFill>
+                  <a:srgbClr val="005448"/>
+                </a:solidFill>
+              </a:rPr>
+              <a:t>• Voice Transcription Latency: </a:t>
+            </a:r>
+            <a:r>
+              <a:rPr sz="1100">
+                <a:solidFill>
+                  <a:srgbClr val="576361"/>
+                </a:solidFill>
+              </a:rPr>
+              <a:t>Sub-second speech-to-text response via on-device speech engine.</a:t>
+            </a:r>
+          </a:p>
+          <a:p>
+            <a:pPr>
+              <a:spcAft>
+                <a:spcPts val="200"/>
+              </a:spcAft>
+            </a:pPr>
+            <a:r>
+              <a:rPr b="1" sz="1100">
+                <a:solidFill>
+                  <a:srgbClr val="005448"/>
+                </a:solidFill>
+              </a:rPr>
+              <a:t>• Chat Layout Clearance: </a:t>
+            </a:r>
+            <a:r>
+              <a:rPr sz="1100">
+                <a:solidFill>
+                  <a:srgbClr val="576361"/>
+                </a:solidFill>
+              </a:rPr>
+              <a:t>Elevated input card floats cleanly above bottom navigation bar with zero occlusion.</a:t>
+            </a:r>
+          </a:p>
+          <a:p>
+            <a:pPr>
+              <a:spcAft>
+                <a:spcPts val="200"/>
+              </a:spcAft>
+            </a:pPr>
+            <a:r>
+              <a:rPr b="1" sz="1100">
+                <a:solidFill>
+                  <a:srgbClr val="005448"/>
+                </a:solidFill>
+              </a:rPr>
+              <a:t>• APK Footprint: </a:t>
+            </a:r>
+            <a:r>
+              <a:rPr sz="1100">
+                <a:solidFill>
+                  <a:srgbClr val="576361"/>
+                </a:solidFill>
+              </a:rPr>
+              <a:t>Ultra-lightweight ~4.1 MB distribution size, ideal for 2G/3G rural network downloads.</a:t>
             </a:r>
           </a:p>
         </p:txBody>
@@ -6696,18 +6842,18 @@
         </p:nvSpPr>
         <p:spPr>
           <a:xfrm>
-            <a:off x="1097280" y="640080"/>
-            <a:ext cx="9997135" cy="5577840"/>
+            <a:off x="1097280" y="685800"/>
+            <a:ext cx="9997135" cy="5486400"/>
           </a:xfrm>
           <a:prstGeom prst="roundRect">
             <a:avLst/>
           </a:prstGeom>
           <a:solidFill>
-            <a:srgbClr val="0B1413"/>
+            <a:srgbClr val="FBFAF6"/>
           </a:solidFill>
-          <a:ln w="19050">
+          <a:ln w="31750">
             <a:solidFill>
-              <a:srgbClr val="10B981"/>
+              <a:srgbClr val="E0F2EE"/>
             </a:solidFill>
           </a:ln>
         </p:spPr>
@@ -6731,26 +6877,29 @@
           <a:p>
             <a:pPr algn="ctr">
               <a:spcAft>
-                <a:spcPts val="1000"/>
-              </a:spcAft>
-              <a:defRPr b="1" sz="1200">
-                <a:solidFill>
-                  <a:srgbClr val="10B981"/>
-                </a:solidFill>
-              </a:defRPr>
-            </a:pPr>
-            <a:r>
-              <a:t>NATIONAL HACKATHON 2026  •  FINAL PITCH</a:t>
+                <a:spcPts val="600"/>
+              </a:spcAft>
+              <a:defRPr b="1" sz="1100">
+                <a:solidFill>
+                  <a:srgbClr val="005448"/>
+                </a:solidFill>
+              </a:defRPr>
+            </a:pPr>
+            <a:br/>
+            <a:br/>
+            <a:br/>
+            <a:r>
+              <a:t>NATIONAL LEVEL HACKATHON 2026  •  FINAL PITCH</a:t>
             </a:r>
           </a:p>
           <a:p>
             <a:pPr algn="ctr">
               <a:spcAft>
-                <a:spcPts val="800"/>
-              </a:spcAft>
-              <a:defRPr b="1" sz="3600">
-                <a:solidFill>
-                  <a:srgbClr val="FFFFFF"/>
+                <a:spcPts val="600"/>
+              </a:spcAft>
+              <a:defRPr b="1" sz="3200">
+                <a:solidFill>
+                  <a:srgbClr val="121E1C"/>
                 </a:solidFill>
               </a:defRPr>
             </a:pPr>
@@ -6761,11 +6910,11 @@
           <a:p>
             <a:pPr algn="ctr">
               <a:spcAft>
-                <a:spcPts val="2400"/>
+                <a:spcPts val="1800"/>
               </a:spcAft>
               <a:defRPr sz="1400">
                 <a:solidFill>
-                  <a:srgbClr val="FBFAF6"/>
+                  <a:srgbClr val="576361"/>
                 </a:solidFill>
               </a:defRPr>
             </a:pPr>
@@ -6774,31 +6923,55 @@
             </a:r>
             <a:br/>
             <a:r>
-              <a:t>It bridges the 40-km healthcare desert using the phone in every villager's pocket.</a:t>
-            </a:r>
-          </a:p>
-        </p:txBody>
-      </p:sp>
-      <p:sp>
-        <p:nvSpPr>
-          <p:cNvPr id="4" name="Rounded Rectangle 3"/>
+              <a:t>It bridges the 40-km healthcare desert using the smartphone in every villager's pocket.</a:t>
+            </a:r>
+          </a:p>
+        </p:txBody>
+      </p:sp>
+      <p:pic>
+        <p:nvPicPr>
+          <p:cNvPr id="4" name="Picture 3" descr="logo.jpg"/>
+          <p:cNvPicPr>
+            <a:picLocks noChangeAspect="1"/>
+          </p:cNvPicPr>
+          <p:nvPr/>
+        </p:nvPicPr>
+        <p:blipFill>
+          <a:blip r:embed="rId2"/>
+          <a:stretch>
+            <a:fillRect/>
+          </a:stretch>
+        </p:blipFill>
+        <p:spPr>
+          <a:xfrm>
+            <a:off x="5546750" y="960120"/>
+            <a:ext cx="1097280" cy="1097280"/>
+          </a:xfrm>
+          <a:prstGeom prst="rect">
+            <a:avLst/>
+          </a:prstGeom>
+        </p:spPr>
+      </p:pic>
+      <p:sp>
+        <p:nvSpPr>
+          <p:cNvPr id="5" name="Rounded Rectangle 4"/>
           <p:cNvSpPr/>
           <p:nvPr/>
         </p:nvSpPr>
         <p:spPr>
           <a:xfrm>
-            <a:off x="1645920" y="3657600"/>
-            <a:ext cx="2468880" cy="2103120"/>
+            <a:off x="1645920" y="4114800"/>
+            <a:ext cx="2468880" cy="1737360"/>
           </a:xfrm>
           <a:prstGeom prst="roundRect">
             <a:avLst/>
           </a:prstGeom>
           <a:solidFill>
-            <a:srgbClr val="14211F"/>
+            <a:srgbClr val="FFFFFF"/>
           </a:solidFill>
-          <a:ln w="19050">
+          <a:ln w="15240">
             <a:solidFill>
-              <a:srgbClr val="233734"/>
+              <a:srgbClr val="E8E6DF"/>
             </a:solidFill>
           </a:ln>
         </p:spPr>
@@ -6822,11 +6995,11 @@
           <a:p>
             <a:pPr algn="ctr">
               <a:spcAft>
-                <a:spcPts val="600"/>
-              </a:spcAft>
-              <a:defRPr b="1" sz="1300">
-                <a:solidFill>
-                  <a:srgbClr val="34D399"/>
+                <a:spcPts val="400"/>
+              </a:spcAft>
+              <a:defRPr b="1" sz="1200">
+                <a:solidFill>
+                  <a:srgbClr val="005448"/>
                 </a:solidFill>
               </a:defRPr>
             </a:pPr>
@@ -6836,38 +7009,38 @@
           </a:p>
           <a:p>
             <a:pPr>
-              <a:defRPr sz="1050">
-                <a:solidFill>
-                  <a:srgbClr val="A0AFAA"/>
-                </a:solidFill>
-              </a:defRPr>
-            </a:pPr>
-            <a:r>
-              <a:t>Seed partnership with National Health Mission (NHM) Kerala to pilot across 4 rural panchayats in Kottayam district.</a:t>
-            </a:r>
-          </a:p>
-        </p:txBody>
-      </p:sp>
-      <p:sp>
-        <p:nvSpPr>
-          <p:cNvPr id="5" name="Rounded Rectangle 4"/>
+              <a:defRPr sz="1000">
+                <a:solidFill>
+                  <a:srgbClr val="576361"/>
+                </a:solidFill>
+              </a:defRPr>
+            </a:pPr>
+            <a:r>
+              <a:t>Partnership with National Health Mission (NHM) Kerala to pilot across 4 rural panchayats in Kottayam district.</a:t>
+            </a:r>
+          </a:p>
+        </p:txBody>
+      </p:sp>
+      <p:sp>
+        <p:nvSpPr>
+          <p:cNvPr id="6" name="Rounded Rectangle 5"/>
           <p:cNvSpPr/>
           <p:nvPr/>
         </p:nvSpPr>
         <p:spPr>
           <a:xfrm>
-            <a:off x="4480560" y="3657600"/>
-            <a:ext cx="2468880" cy="2103120"/>
+            <a:off x="4480560" y="4114800"/>
+            <a:ext cx="2468880" cy="1737360"/>
           </a:xfrm>
           <a:prstGeom prst="roundRect">
             <a:avLst/>
           </a:prstGeom>
           <a:solidFill>
-            <a:srgbClr val="14211F"/>
+            <a:srgbClr val="FFFFFF"/>
           </a:solidFill>
-          <a:ln w="19050">
+          <a:ln w="15240">
             <a:solidFill>
-              <a:srgbClr val="233734"/>
+              <a:srgbClr val="E8E6DF"/>
             </a:solidFill>
           </a:ln>
         </p:spPr>
@@ -6891,52 +7064,52 @@
           <a:p>
             <a:pPr algn="ctr">
               <a:spcAft>
-                <a:spcPts val="600"/>
-              </a:spcAft>
-              <a:defRPr b="1" sz="1300">
-                <a:solidFill>
-                  <a:srgbClr val="34D399"/>
-                </a:solidFill>
-              </a:defRPr>
-            </a:pPr>
-            <a:r>
-              <a:t>🔬  Immediate Next Steps</a:t>
-            </a:r>
-          </a:p>
-          <a:p>
-            <a:pPr>
-              <a:defRPr sz="1050">
-                <a:solidFill>
-                  <a:srgbClr val="A0AFAA"/>
-                </a:solidFill>
-              </a:defRPr>
-            </a:pPr>
-            <a:r>
-              <a:t>ASHA worker beta group onboarding, Supabase database synchronization, and local ABDM health registry linking.</a:t>
-            </a:r>
-          </a:p>
-        </p:txBody>
-      </p:sp>
-      <p:sp>
-        <p:nvSpPr>
-          <p:cNvPr id="6" name="Rounded Rectangle 5"/>
+                <a:spcPts val="400"/>
+              </a:spcAft>
+              <a:defRPr b="1" sz="1200">
+                <a:solidFill>
+                  <a:srgbClr val="005448"/>
+                </a:solidFill>
+              </a:defRPr>
+            </a:pPr>
+            <a:r>
+              <a:t>🔬  Next Steps</a:t>
+            </a:r>
+          </a:p>
+          <a:p>
+            <a:pPr>
+              <a:defRPr sz="1000">
+                <a:solidFill>
+                  <a:srgbClr val="576361"/>
+                </a:solidFill>
+              </a:defRPr>
+            </a:pPr>
+            <a:r>
+              <a:t>ASHA worker beta group onboarding, Supabase database sync, and ABDM health ID integration.</a:t>
+            </a:r>
+          </a:p>
+        </p:txBody>
+      </p:sp>
+      <p:sp>
+        <p:nvSpPr>
+          <p:cNvPr id="7" name="Rounded Rectangle 6"/>
           <p:cNvSpPr/>
           <p:nvPr/>
         </p:nvSpPr>
         <p:spPr>
           <a:xfrm>
-            <a:off x="7315200" y="3657600"/>
-            <a:ext cx="2468880" cy="2103120"/>
+            <a:off x="7315200" y="4114800"/>
+            <a:ext cx="2468880" cy="1737360"/>
           </a:xfrm>
           <a:prstGeom prst="roundRect">
             <a:avLst/>
           </a:prstGeom>
           <a:solidFill>
-            <a:srgbClr val="14211F"/>
+            <a:srgbClr val="FFFFFF"/>
           </a:solidFill>
-          <a:ln w="19050">
+          <a:ln w="15240">
             <a:solidFill>
-              <a:srgbClr val="233734"/>
+              <a:srgbClr val="E8E6DF"/>
             </a:solidFill>
           </a:ln>
         </p:spPr>
@@ -6960,11 +7133,11 @@
           <a:p>
             <a:pPr algn="ctr">
               <a:spcAft>
-                <a:spcPts val="600"/>
-              </a:spcAft>
-              <a:defRPr b="1" sz="1300">
-                <a:solidFill>
-                  <a:srgbClr val="34D399"/>
+                <a:spcPts val="400"/>
+              </a:spcAft>
+              <a:defRPr b="1" sz="1200">
+                <a:solidFill>
+                  <a:srgbClr val="005448"/>
                 </a:solidFill>
               </a:defRPr>
             </a:pPr>
@@ -6974,9 +7147,9 @@
           </a:p>
           <a:p>
             <a:pPr>
-              <a:defRPr sz="1050">
-                <a:solidFill>
-                  <a:srgbClr val="A0AFAA"/>
+              <a:defRPr sz="1000">
+                <a:solidFill>
+                  <a:srgbClr val="576361"/>
                 </a:solidFill>
               </a:defRPr>
             </a:pPr>

</xml_diff>